<commit_message>
Implemented unit-wise AI PPT generation with download support
</commit_message>
<xml_diff>
--- a/generated_ppts/Applications of AI.pptx
+++ b/generated_ppts/Applications of AI.pptx
@@ -55,7 +55,6 @@
     <p:sldId id="303" r:id="rId54"/>
     <p:sldId id="304" r:id="rId55"/>
     <p:sldId id="305" r:id="rId56"/>
-    <p:sldId id="306" r:id="rId57"/>
   </p:sldIdLst>
   <p:sldSz cx="9144000" cy="6858000" type="screen4x3"/>
   <p:notesSz cx="6858000" cy="9144000"/>
@@ -3154,7 +3153,7 @@
           <a:lstStyle/>
           <a:p>
             <a:r>
-              <a:t>Unit Introduction: Applications of AI</a:t>
+              <a:t>Introduction to AI and Logic</a:t>
             </a:r>
           </a:p>
         </p:txBody>
@@ -3175,27 +3174,27 @@
           <a:lstStyle/>
           <a:p>
             <a:r>
-              <a:t>Welcome to the 'Applications of AI' unit, exploring foundational and modern AI paradigms.</a:t>
-            </a:r>
-          </a:p>
-          <a:p>
-            <a:r>
-              <a:t>This unit delves into both symbolic AI approaches, focusing on knowledge representation and reasoning.</a:t>
-            </a:r>
-          </a:p>
-          <a:p>
-            <a:r>
-              <a:t>We will also explore the paradigm shift towards machine learning, understanding its core concepts and methodologies.</a:t>
-            </a:r>
-          </a:p>
-          <a:p>
-            <a:r>
-              <a:t>Emphasis will be placed on practical applications and the underlying theoretical principles of each AI technique.</a:t>
-            </a:r>
-          </a:p>
-          <a:p>
-            <a:r>
-              <a:t>Prepare to engage with concepts from formal logic to complex data-driven predictive models.</a:t>
+              <a:t>Artificial Intelligence (AI) often aims to enable machines to think and reason like humans or to solve complex problems intelligently.</a:t>
+            </a:r>
+          </a:p>
+          <a:p>
+            <a:r>
+              <a:t>Symbolic AI, a foundational paradigm, heavily relies on formal logic systems to represent knowledge and perform inference.</a:t>
+            </a:r>
+          </a:p>
+          <a:p>
+            <a:r>
+              <a:t>Logic provides a precise, unambiguous language for encoding information and rules, facilitating automated reasoning processes.</a:t>
+            </a:r>
+          </a:p>
+          <a:p>
+            <a:r>
+              <a:t>It allows for explicit representation of facts and relationships, making it possible to derive new conclusions through logical deduction.</a:t>
+            </a:r>
+          </a:p>
+          <a:p>
+            <a:r>
+              <a:t>Early AI systems, like theorem provers and expert systems, demonstrated the power of logical approaches in problem-solving.</a:t>
             </a:r>
           </a:p>
         </p:txBody>
@@ -3234,7 +3233,7 @@
           <a:lstStyle/>
           <a:p>
             <a:r>
-              <a:t>Quantifiers and Their Use</a:t>
+              <a:t>Resolution Principle in Predicate Logic</a:t>
             </a:r>
           </a:p>
         </p:txBody>
@@ -3255,27 +3254,32 @@
           <a:lstStyle/>
           <a:p>
             <a:r>
-              <a:t>Quantifiers allow expressing statements about collections of objects rather than just individuals.</a:t>
-            </a:r>
-          </a:p>
-          <a:p>
-            <a:r>
-              <a:t>The Universal Quantifier (∀, 'for all') asserts that a property holds for every object in the domain.</a:t>
-            </a:r>
-          </a:p>
-          <a:p>
-            <a:r>
-              <a:t>Example: ∀x (IsHuman(x) → HasTwoLegs(x)) means 'All humans have two legs'.</a:t>
-            </a:r>
-          </a:p>
-          <a:p>
-            <a:r>
-              <a:t>The Existential Quantifier (∃, 'there exists') asserts that a property holds for at least one object in the domain.</a:t>
-            </a:r>
-          </a:p>
-          <a:p>
-            <a:r>
-              <a:t>Example: ∃x (IsStudent(x) ∧ StudiesAI(x)) means 'There exists at least one student who studies AI'.</a:t>
+              <a:t>The Resolution Principle is a powerful inference rule often used in automated theorem proving and logic programming (e.g., Prolog).</a:t>
+            </a:r>
+          </a:p>
+          <a:p>
+            <a:r>
+              <a:t>It operates on clauses (disjunctions of literals) after converting all sentences in a knowledge base to Conjunctive Normal Form (CNF).</a:t>
+            </a:r>
+          </a:p>
+          <a:p>
+            <a:r>
+              <a:t>The goal is to prove a sentence by refutation: assume its negation, add it to the knowledge base, and attempt to derive a contradiction (the empty clause).</a:t>
+            </a:r>
+          </a:p>
+          <a:p>
+            <a:r>
+              <a:t>The core resolution step involves taking two clauses with complementary literals (e.g., P and ¬P) and producing a new clause (resolvent).</a:t>
+            </a:r>
+          </a:p>
+          <a:p>
+            <a:r>
+              <a:t>For predicate logic, unification is required before resolution, finding substitutions for variables to make two literals identical.</a:t>
+            </a:r>
+          </a:p>
+          <a:p>
+            <a:r>
+              <a:t>Resolution is sound and complete for first-order logic, capable of proving any valid conclusion that logically follows from premises.</a:t>
             </a:r>
           </a:p>
         </p:txBody>
@@ -3314,7 +3318,7 @@
           <a:lstStyle/>
           <a:p>
             <a:r>
-              <a:t>Inference in Predicate Logic</a:t>
+              <a:t>Introduction to Semantic Networks</a:t>
             </a:r>
           </a:p>
         </p:txBody>
@@ -3335,27 +3339,27 @@
           <a:lstStyle/>
           <a:p>
             <a:r>
-              <a:t>Inference in FOL is more complex than PL due to variables and quantifiers, requiring more sophisticated methods.</a:t>
-            </a:r>
-          </a:p>
-          <a:p>
-            <a:r>
-              <a:t>Generalization (Universal Elimination) allows inferring specific instances from universally quantified statements.</a:t>
-            </a:r>
-          </a:p>
-          <a:p>
-            <a:r>
-              <a:t>Unification is a key process that finds substitutions for variables to make two logical expressions identical.</a:t>
-            </a:r>
-          </a:p>
-          <a:p>
-            <a:r>
-              <a:t>Resolution in FOL extends propositional resolution by incorporating unification to handle variables and generate new clauses.</a:t>
-            </a:r>
-          </a:p>
-          <a:p>
-            <a:r>
-              <a:t>Skolemization is used to eliminate existential quantifiers by introducing Skolem constants or functions to simplify formulas for resolution.</a:t>
+              <a:t>Semantic networks are a knowledge representation technique that uses a graph structure to represent concepts and the relationships between them.</a:t>
+            </a:r>
+          </a:p>
+          <a:p>
+            <a:r>
+              <a:t>Developed in the 1960s, they aim to model human semantic memory and are intuitive for representing taxonomic and associative knowledge.</a:t>
+            </a:r>
+          </a:p>
+          <a:p>
+            <a:r>
+              <a:t>The network consists of nodes (or concepts) and links (or arcs) connecting these nodes, representing relationships.</a:t>
+            </a:r>
+          </a:p>
+          <a:p>
+            <a:r>
+              <a:t>Nodes typically represent objects, concepts, or events, while links represent the relationships between them (e.g., 'is-a', 'has-a', 'part-of').</a:t>
+            </a:r>
+          </a:p>
+          <a:p>
+            <a:r>
+              <a:t>This visual and structured approach makes semantic networks easy to understand and effective for certain types of knowledge organization and retrieval.</a:t>
             </a:r>
           </a:p>
         </p:txBody>
@@ -3394,7 +3398,7 @@
           <a:lstStyle/>
           <a:p>
             <a:r>
-              <a:t>Semantic Networks: Visualizing Knowledge</a:t>
+              <a:t>Nodes and Arcs: Representing Knowledge</a:t>
             </a:r>
           </a:p>
         </p:txBody>
@@ -3415,27 +3419,27 @@
           <a:lstStyle/>
           <a:p>
             <a:r>
-              <a:t>Semantic Networks are a knowledge representation technique that visually represents concepts and their relationships.</a:t>
-            </a:r>
-          </a:p>
-          <a:p>
-            <a:r>
-              <a:t>They use a graph structure where nodes represent concepts, objects, or events.</a:t>
-            </a:r>
-          </a:p>
-          <a:p>
-            <a:r>
-              <a:t>Arcs (or links) represent relationships between these nodes, illustrating how concepts connect.</a:t>
-            </a:r>
-          </a:p>
-          <a:p>
-            <a:r>
-              <a:t>Semantic networks are intuitive and human-readable, making complex relationships easier to understand.</a:t>
-            </a:r>
-          </a:p>
-          <a:p>
-            <a:r>
-              <a:t>They provide a flexible way to model diverse types of knowledge, from taxonomic hierarchies to causal relationships.</a:t>
+              <a:t>Nodes: Depicted as circles or rectangles, representing entities like individuals ('Socrates'), classes ('Human'), or properties ('Color').</a:t>
+            </a:r>
+          </a:p>
+          <a:p>
+            <a:r>
+              <a:t>Arcs (Links/Edges): Connect nodes and represent labeled, directed relationships between them.</a:t>
+            </a:r>
+          </a:p>
+          <a:p>
+            <a:r>
+              <a:t>Common link types include: IS-A (or AKO - A Kind Of) for class-subclass relationships (e.g., 'Dog IS-A Mammal').</a:t>
+            </a:r>
+          </a:p>
+          <a:p>
+            <a:r>
+              <a:t>HAS-A (or PART-OF) for part-whole relationships (e.g., 'Car HAS-A Wheel').</a:t>
+            </a:r>
+          </a:p>
+          <a:p>
+            <a:r>
+              <a:t>Other links can represent attributes, actions (Agent, Object), or temporal relations.</a:t>
             </a:r>
           </a:p>
         </p:txBody>
@@ -3474,7 +3478,7 @@
           <a:lstStyle/>
           <a:p>
             <a:r>
-              <a:t>What are Semantic Networks?</a:t>
+              <a:t>Inheritance and IS-A/HAS-A Relationships</a:t>
             </a:r>
           </a:p>
         </p:txBody>
@@ -3495,27 +3499,27 @@
           <a:lstStyle/>
           <a:p>
             <a:r>
-              <a:t>A semantic network is a directed or undirected graph consisting of nodes and labeled edges (arcs).</a:t>
-            </a:r>
-          </a:p>
-          <a:p>
-            <a:r>
-              <a:t>Nodes typically represent entities, attributes, or values (e.g., 'Dog', 'Mammal', 'HasTail').</a:t>
-            </a:r>
-          </a:p>
-          <a:p>
-            <a:r>
-              <a:t>Edges represent semantic relations between nodes (e.g., 'is-a', 'has-part', 'can-do').</a:t>
-            </a:r>
-          </a:p>
-          <a:p>
-            <a:r>
-              <a:t>The 'is-a' link is particularly important for representing class-subclass relationships and inheritance.</a:t>
-            </a:r>
-          </a:p>
-          <a:p>
-            <a:r>
-              <a:t>Early examples include Quillian's Teachable Language Comprehender and the network models used in natural language processing.</a:t>
+              <a:t>Inheritance: A key feature where properties and attributes defined for a superclass are automatically inherited by its subclasses through IS-A links.</a:t>
+            </a:r>
+          </a:p>
+          <a:p>
+            <a:r>
+              <a:t>For example, if 'Mammal' has 'has_warm_blood,' then 'Dog' (which IS-A Mammal) inherits this property, promoting knowledge efficiency.</a:t>
+            </a:r>
+          </a:p>
+          <a:p>
+            <a:r>
+              <a:t>IS-A (A Kind Of) links define taxonomic hierarchies and are crucial for enabling property inheritance from parent to child nodes.</a:t>
+            </a:r>
+          </a:p>
+          <a:p>
+            <a:r>
+              <a:t>HAS-A (Part-Of) links represent meronymic relationships, where one entity is a component of another, but typically do not support property inheritance in the same way as IS-A.</a:t>
+            </a:r>
+          </a:p>
+          <a:p>
+            <a:r>
+              <a:t>The interplay of IS-A and HAS-A allows for comprehensive modeling of object hierarchies and their compositions, forming a robust structure for knowledge organization.</a:t>
             </a:r>
           </a:p>
         </p:txBody>
@@ -3554,7 +3558,7 @@
           <a:lstStyle/>
           <a:p>
             <a:r>
-              <a:t>Components of Semantic Networks</a:t>
+              <a:t>Advantages and Disadvantages of Semantic Networks</a:t>
             </a:r>
           </a:p>
         </p:txBody>
@@ -3575,27 +3579,32 @@
           <a:lstStyle/>
           <a:p>
             <a:r>
-              <a:t>Nodes: Abstract concepts, concrete objects, or instances in the knowledge domain.</a:t>
-            </a:r>
-          </a:p>
-          <a:p>
-            <a:r>
-              <a:t>Edges (Links/Arcs): Labeled connections between nodes, representing specific relationships.</a:t>
-            </a:r>
-          </a:p>
-          <a:p>
-            <a:r>
-              <a:t>Common link types: 'is-a' (subclass/superclass), 'part-of' (component/whole), 'has-property' (object/attribute).</a:t>
-            </a:r>
-          </a:p>
-          <a:p>
-            <a:r>
-              <a:t>Directed edges indicate the direction of the relationship (e.g., 'A_is_a_B' implies 'A' is a specific kind of 'B').</a:t>
-            </a:r>
-          </a:p>
-          <a:p>
-            <a:r>
-              <a:t>The network's structure allows for visual representation of ontological relationships and object properties.</a:t>
+              <a:t>Advantages: Intuitive and visual representation, flexible for various relationships, efficient inheritance mechanisms, and supports path finding for information retrieval.</a:t>
+            </a:r>
+          </a:p>
+          <a:p>
+            <a:r>
+              <a:t>Disadvantages: Lack of formal semantics can lead to ambiguity in interpretation of nodes and links.</a:t>
+            </a:r>
+          </a:p>
+          <a:p>
+            <a:r>
+              <a:t>Limited expressiveness for complex logical statements, quantifiers, or higher-order relationships found in predicate logic.</a:t>
+            </a:r>
+          </a:p>
+          <a:p>
+            <a:r>
+              <a:t>Can face scalability challenges for very large knowledge bases, becoming unwieldy and difficult to manage.</a:t>
+            </a:r>
+          </a:p>
+          <a:p>
+            <a:r>
+              <a:t>Inference mechanisms are often heuristic and lack the formal soundness and completeness of logic-based systems.</a:t>
+            </a:r>
+          </a:p>
+          <a:p>
+            <a:r>
+              <a:t>No standardized representation for link types, making integration and interoperability difficult across different networks.</a:t>
             </a:r>
           </a:p>
         </p:txBody>
@@ -3634,7 +3643,7 @@
           <a:lstStyle/>
           <a:p>
             <a:r>
-              <a:t>Inheritance and Default Reasoning</a:t>
+              <a:t>Applications and Extensions (e.g., Description Logics)</a:t>
             </a:r>
           </a:p>
         </p:txBody>
@@ -3655,27 +3664,32 @@
           <a:lstStyle/>
           <a:p>
             <a:r>
-              <a:t>Semantic networks inherently support inheritance, where properties of a superclass are inherited by its subclasses.</a:t>
-            </a:r>
-          </a:p>
-          <a:p>
-            <a:r>
-              <a:t>For example, if 'Mammal has-property Warm-Blooded', then 'Dog', being a 'is-a Mammal', inherits 'Warm-Blooded'.</a:t>
-            </a:r>
-          </a:p>
-          <a:p>
-            <a:r>
-              <a:t>This reduces redundancy in knowledge representation and allows for efficient retrieval of information.</a:t>
-            </a:r>
-          </a:p>
-          <a:p>
-            <a:r>
-              <a:t>Default reasoning can also be modeled, allowing subclasses to override inherited properties (e.g., 'Ostrich is-a Bird' but 'Ostrich can-not fly').</a:t>
-            </a:r>
-          </a:p>
-          <a:p>
-            <a:r>
-              <a:t>However, managing exceptions and conflicting inherited properties can become complex in large networks.</a:t>
+              <a:t>Applications: Used in Natural Language Processing (NLP) for word sense disambiguation, knowledge-based systems, information retrieval, and cognitive modeling.</a:t>
+            </a:r>
+          </a:p>
+          <a:p>
+            <a:r>
+              <a:t>Conceptual Graphs: A logic-based notation for semantic networks, providing a formal foundation in first-order logic.</a:t>
+            </a:r>
+          </a:p>
+          <a:p>
+            <a:r>
+              <a:t>Description Logics (DLs): A family of formal knowledge representation languages, a subset of first-order logic, balancing expressiveness and tractability.</a:t>
+            </a:r>
+          </a:p>
+          <a:p>
+            <a:r>
+              <a:t>DLs are the logical underpinning of ontologies and the Semantic Web, enabling robust inference and reasoning.</a:t>
+            </a:r>
+          </a:p>
+          <a:p>
+            <a:r>
+              <a:t>RDF (Resource Description Framework) and OWL (Web Ontology Language): W3C standards for representing knowledge on the Semantic Web, essentially formalized and highly expressive semantic networks.</a:t>
+            </a:r>
+          </a:p>
+          <a:p>
+            <a:r>
+              <a:t>These extensions address traditional semantic network limitations by providing formal semantics, increased expressiveness, and robust inference mechanisms.</a:t>
             </a:r>
           </a:p>
         </p:txBody>
@@ -3714,7 +3728,7 @@
           <a:lstStyle/>
           <a:p>
             <a:r>
-              <a:t>Strengths and Weaknesses of Semantic Networks</a:t>
+              <a:t>Introduction to Frames</a:t>
             </a:r>
           </a:p>
         </p:txBody>
@@ -3735,27 +3749,27 @@
           <a:lstStyle/>
           <a:p>
             <a:r>
-              <a:t>Strengths: Intuitive visual representation, good for hierarchical and relational knowledge, efficient inheritance mechanisms.</a:t>
-            </a:r>
-          </a:p>
-          <a:p>
-            <a:r>
-              <a:t>They are particularly effective for knowledge domains with well-defined categories and relationships.</a:t>
-            </a:r>
-          </a:p>
-          <a:p>
-            <a:r>
-              <a:t>Weaknesses: Representing complex logical constructs (e.g., disjunction, negation, quantification) can be awkward or impossible.</a:t>
-            </a:r>
-          </a:p>
-          <a:p>
-            <a:r>
-              <a:t>The meaning of links can sometimes be ambiguous without strict formalization, leading to misinterpretations.</a:t>
-            </a:r>
-          </a:p>
-          <a:p>
-            <a:r>
-              <a:t>Scalability issues arise with extremely large networks where managing consistency and search paths becomes challenging.</a:t>
+              <a:t>Frames, introduced by Marvin Minsky in 1974, are a knowledge representation technique inspired by how humans organize their knowledge about stereotypical situations.</a:t>
+            </a:r>
+          </a:p>
+          <a:p>
+            <a:r>
+              <a:t>A frame is a data structure representing a stereotypical object, concept, or event, acting as a template for a situation.</a:t>
+            </a:r>
+          </a:p>
+          <a:p>
+            <a:r>
+              <a:t>Each frame consists of a collection of 'slots,' which represent attributes or properties associated with the concept the frame describes.</a:t>
+            </a:r>
+          </a:p>
+          <a:p>
+            <a:r>
+              <a:t>Slots can hold values (actual data) or 'facets' which describe aspects of the slot itself, such as default values, data types, or procedural attachments.</a:t>
+            </a:r>
+          </a:p>
+          <a:p>
+            <a:r>
+              <a:t>Frames provide a structured, object-oriented approach to knowledge representation, facilitating efficient retrieval and reasoning about specific instances.</a:t>
             </a:r>
           </a:p>
         </p:txBody>
@@ -3794,7 +3808,7 @@
           <a:lstStyle/>
           <a:p>
             <a:r>
-              <a:t>Beyond Simple Networks: Structured Knowledge</a:t>
+              <a:t>Frame Slots and Facets</a:t>
             </a:r>
           </a:p>
         </p:txBody>
@@ -3815,27 +3829,32 @@
           <a:lstStyle/>
           <a:p>
             <a:r>
-              <a:t>While semantic networks are powerful, they can become cumbersome for representing highly structured, stereotypical knowledge.</a:t>
-            </a:r>
-          </a:p>
-          <a:p>
-            <a:r>
-              <a:t>Complex real-world scenarios often involve knowledge that is organized into typical situations, objects, or events.</a:t>
-            </a:r>
-          </a:p>
-          <a:p>
-            <a:r>
-              <a:t>This led to the development of more organized knowledge representation schemes like frames and scripts.</a:t>
-            </a:r>
-          </a:p>
-          <a:p>
-            <a:r>
-              <a:t>These approaches aim to capture the 'common sense' expectations associated with various entities and situations.</a:t>
-            </a:r>
-          </a:p>
-          <a:p>
-            <a:r>
-              <a:t>They provide a framework for organizing related pieces of information into coherent, reusable units.</a:t>
+              <a:t>Slots: Core components of a frame, representing attributes, properties, or relationships of the entity the frame describes (e.g., 'Manufacturer', 'Model' in a Car frame).</a:t>
+            </a:r>
+          </a:p>
+          <a:p>
+            <a:r>
+              <a:t>Slots can be filled with specific values for an instance (e.g., MyCar.Color = 'Red').</a:t>
+            </a:r>
+          </a:p>
+          <a:p>
+            <a:r>
+              <a:t>Facets: Provide additional information or constraints about a slot, defining how its value is determined, interpreted, or constrained.</a:t>
+            </a:r>
+          </a:p>
+          <a:p>
+            <a:r>
+              <a:t>Common facets include: Default values (e.g., NumberOfDoors default to 4 for a Sedan frame).</a:t>
+            </a:r>
+          </a:p>
+          <a:p>
+            <a:r>
+              <a:t>Value type and Range: Specify data type and permissible values (e.g., EngineSize between 1.0 and 5.0 liters).</a:t>
+            </a:r>
+          </a:p>
+          <a:p>
+            <a:r>
+              <a:t>If-added/If-needed procedures (Demons): Functions triggered when a value is added or requested, allowing for procedural knowledge.</a:t>
             </a:r>
           </a:p>
         </p:txBody>
@@ -3874,7 +3893,7 @@
           <a:lstStyle/>
           <a:p>
             <a:r>
-              <a:t>Frames: Structure and Slots</a:t>
+              <a:t>Inheritance and Defaults in Frames</a:t>
             </a:r>
           </a:p>
         </p:txBody>
@@ -3895,27 +3914,32 @@
           <a:lstStyle/>
           <a:p>
             <a:r>
-              <a:t>A frame is a data structure for representing a stereotypical situation, object, or event.</a:t>
-            </a:r>
-          </a:p>
-          <a:p>
-            <a:r>
-              <a:t>It consists of a collection of 'slots' and 'fillers' that describe the attributes and values of the entity being represented.</a:t>
-            </a:r>
-          </a:p>
-          <a:p>
-            <a:r>
-              <a:t>Slots can contain various types of information: default values, rules, procedures, other frames, or even pointers to other frames.</a:t>
-            </a:r>
-          </a:p>
-          <a:p>
-            <a:r>
-              <a:t>Example: A 'Car' frame might have slots for 'Manufacturer', 'Model', 'Color', 'EngineType', 'Number_of_Wheels'.</a:t>
-            </a:r>
-          </a:p>
-          <a:p>
-            <a:r>
-              <a:t>Frames provide a strong organizational principle, allowing for structured knowledge representation.</a:t>
+              <a:t>Inheritance: Frames are organized into hierarchies, allowing properties (slots and facets) to be inherited from more general frames to more specific ones, reducing redundancy.</a:t>
+            </a:r>
+          </a:p>
+          <a:p>
+            <a:r>
+              <a:t>A 'subframe' (instance or subclass) automatically inherits all slots and their facets from its 'superframe' (parent class).</a:t>
+            </a:r>
+          </a:p>
+          <a:p>
+            <a:r>
+              <a:t>This mechanism significantly reduces redundancy and simplifies knowledge management; changes to a superframe propagate to subframes.</a:t>
+            </a:r>
+          </a:p>
+          <a:p>
+            <a:r>
+              <a:t>Defaults: A crucial aspect allowing specification of default values for slots. If an instance doesn't explicitly provide a value, the default from its superframe is used.</a:t>
+            </a:r>
+          </a:p>
+          <a:p>
+            <a:r>
+              <a:t>Defaults capture stereotypical knowledge and enable efficient reasoning by making reasonable assumptions when information is incomplete.</a:t>
+            </a:r>
+          </a:p>
+          <a:p>
+            <a:r>
+              <a:t>Example: A 'Bird' frame might have 'CanFly: Yes (default)', but a 'Penguin' subframe could override this to 'CanFly: No', handling exceptions gracefully.</a:t>
             </a:r>
           </a:p>
         </p:txBody>
@@ -3954,7 +3978,7 @@
           <a:lstStyle/>
           <a:p>
             <a:r>
-              <a:t>Frame Inheritance and Demons</a:t>
+              <a:t>Introduction to Scripts</a:t>
             </a:r>
           </a:p>
         </p:txBody>
@@ -3975,27 +3999,27 @@
           <a:lstStyle/>
           <a:p>
             <a:r>
-              <a:t>Frames support inheritance, similar to object-oriented programming, where a sub-frame inherits slots and values from its super-frame.</a:t>
-            </a:r>
-          </a:p>
-          <a:p>
-            <a:r>
-              <a:t>This allows for creating hierarchies of frames, reducing redundancy and promoting reusability of knowledge.</a:t>
-            </a:r>
-          </a:p>
-          <a:p>
-            <a:r>
-              <a:t>Default values in slots can be overridden by specific instances or sub-frames, allowing for exceptions.</a:t>
-            </a:r>
-          </a:p>
-          <a:p>
-            <a:r>
-              <a:t>Demons (or procedural attachments) are procedures associated with slots, triggered when a slot is accessed or modified.</a:t>
-            </a:r>
-          </a:p>
-          <a:p>
-            <a:r>
-              <a:t>Examples of demons include 'if-added' (execute when a value is added) and 'if-needed' (compute a value if requested).</a:t>
+              <a:t>Scripts, introduced by Roger Schank and Robert Abelson, are knowledge representation techniques designed to represent stereotypical sequences of events.</a:t>
+            </a:r>
+          </a:p>
+          <a:p>
+            <a:r>
+              <a:t>They are structured representations of common situations, detailing the roles, props, and sequence of actions that typically occur.</a:t>
+            </a:r>
+          </a:p>
+          <a:p>
+            <a:r>
+              <a:t>Scripts are particularly useful for understanding natural language text and making inferences about unstated actions in familiar contexts.</a:t>
+            </a:r>
+          </a:p>
+          <a:p>
+            <a:r>
+              <a:t>They help to fill in the gaps in understanding by providing a default sequence of events when encountering incomplete narratives.</a:t>
+            </a:r>
+          </a:p>
+          <a:p>
+            <a:r>
+              <a:t>The concept is based on the idea that much of human understanding relies on pre-existing knowledge about how common events unfold.</a:t>
             </a:r>
           </a:p>
         </p:txBody>
@@ -4034,7 +4058,7 @@
           <a:lstStyle/>
           <a:p>
             <a:r>
-              <a:t>Logic and Reasoning: The Foundation of AI</a:t>
+              <a:t>Propositional Logic Fundamentals</a:t>
             </a:r>
           </a:p>
         </p:txBody>
@@ -4055,27 +4079,27 @@
           <a:lstStyle/>
           <a:p>
             <a:r>
-              <a:t>Logic and reasoning form the cornerstone of symbolic AI, enabling systems to infer new knowledge from existing facts.</a:t>
-            </a:r>
-          </a:p>
-          <a:p>
-            <a:r>
-              <a:t>This approach aims to mimic human rational thought processes, making explicit knowledge manageable.</a:t>
-            </a:r>
-          </a:p>
-          <a:p>
-            <a:r>
-              <a:t>Knowledge representation in logic involves encoding information as a set of logical sentences or propositions.</a:t>
-            </a:r>
-          </a:p>
-          <a:p>
-            <a:r>
-              <a:t>Reasoning mechanisms then apply inference rules to deduce conclusions, ensuring their validity.</a:t>
-            </a:r>
-          </a:p>
-          <a:p>
-            <a:r>
-              <a:t>It provides a clear, verifiable framework for AI systems, crucial in domains requiring transparency and justification.</a:t>
+              <a:t>Propositional logic (or propositional calculus) is the simplest form of logic, dealing with propositions as atomic declarative statements that are either true or false.</a:t>
+            </a:r>
+          </a:p>
+          <a:p>
+            <a:r>
+              <a:t>Propositions are represented by propositional variables (e.g., P, Q, R), which stand for statements like 'It is raining' or 'The sky is blue.'</a:t>
+            </a:r>
+          </a:p>
+          <a:p>
+            <a:r>
+              <a:t>Logical connectives combine propositions to form more complex sentences: negation (¬), conjunction (∧), disjunction (∨), implication (→), and biconditional (↔).</a:t>
+            </a:r>
+          </a:p>
+          <a:p>
+            <a:r>
+              <a:t>The truth value of a compound proposition is determined solely by the truth values of its constituent propositions and the definitions of the connectives.</a:t>
+            </a:r>
+          </a:p>
+          <a:p>
+            <a:r>
+              <a:t>It forms the basis for understanding more complex logical systems by defining the fundamental operations on truth values.</a:t>
             </a:r>
           </a:p>
         </p:txBody>
@@ -4114,7 +4138,7 @@
           <a:lstStyle/>
           <a:p>
             <a:r>
-              <a:t>Scripts: Representing Event Sequences</a:t>
+              <a:t>Script Components and Event Sequences</a:t>
             </a:r>
           </a:p>
         </p:txBody>
@@ -4135,27 +4159,37 @@
           <a:lstStyle/>
           <a:p>
             <a:r>
-              <a:t>Scripts are a specialized type of frame, proposed by Roger Schank, designed to represent stereotypical sequences of events.</a:t>
-            </a:r>
-          </a:p>
-          <a:p>
-            <a:r>
-              <a:t>They provide a structured representation for common situations like 'going to a restaurant' or 'visiting a doctor'.</a:t>
-            </a:r>
-          </a:p>
-          <a:p>
-            <a:r>
-              <a:t>A script consists of a set of slots describing components like entry conditions, roles, props, scenes, and results.</a:t>
-            </a:r>
-          </a:p>
-          <a:p>
-            <a:r>
-              <a:t>The 'scenes' slot outlines the sequence of actions and events that typically occur in that situation.</a:t>
-            </a:r>
-          </a:p>
-          <a:p>
-            <a:r>
-              <a:t>Scripts help AI systems understand and generate narratives by providing expectations about event flow.</a:t>
+              <a:t>A script typically has several key components: Entry Conditions, Props, Roles, Scenes, and Results.</a:t>
+            </a:r>
+          </a:p>
+          <a:p>
+            <a:r>
+              <a:t>Entry Conditions: Conditions that must be true for the script to be activated (e.g., hungry and has money for 'Restaurant Script').</a:t>
+            </a:r>
+          </a:p>
+          <a:p>
+            <a:r>
+              <a:t>Props: Objects central to the script (e.g., tables, menu, food for 'Restaurant Script').</a:t>
+            </a:r>
+          </a:p>
+          <a:p>
+            <a:r>
+              <a:t>Roles: Actors involved (e.g., customer, waiter, chef).</a:t>
+            </a:r>
+          </a:p>
+          <a:p>
+            <a:r>
+              <a:t>Results: Conditions true after script completion (e.g., customer no longer hungry, less money).</a:t>
+            </a:r>
+          </a:p>
+          <a:p>
+            <a:r>
+              <a:t>Event Sequences (Scenes): The core of a script, detailing the causal and temporal ordering of events. For 'Restaurant Script': Entering, Ordering, Eating, Exiting.</a:t>
+            </a:r>
+          </a:p>
+          <a:p>
+            <a:r>
+              <a:t>Scripts allow AI systems to predict subsequent actions, resolve ambiguities, and answer questions about a situation based on a learned pattern of events.</a:t>
             </a:r>
           </a:p>
         </p:txBody>
@@ -4194,7 +4228,7 @@
           <a:lstStyle/>
           <a:p>
             <a:r>
-              <a:t>Advantages and Applications of Frames and Scripts</a:t>
+              <a:t>Introduction to Expert Systems</a:t>
             </a:r>
           </a:p>
         </p:txBody>
@@ -4215,27 +4249,27 @@
           <a:lstStyle/>
           <a:p>
             <a:r>
-              <a:t>Advantages: Provide a structured and organized way to represent complex knowledge, support default reasoning and inheritance, and handle expectations.</a:t>
-            </a:r>
-          </a:p>
-          <a:p>
-            <a:r>
-              <a:t>Frames are excellent for representing objects, concepts, and classes in a hierarchical manner.</a:t>
-            </a:r>
-          </a:p>
-          <a:p>
-            <a:r>
-              <a:t>Scripts are highly effective for understanding and generating stories or common social situations.</a:t>
-            </a:r>
-          </a:p>
-          <a:p>
-            <a:r>
-              <a:t>Applications include natural language understanding, story comprehension, planning, and expert systems.</a:t>
-            </a:r>
-          </a:p>
-          <a:p>
-            <a:r>
-              <a:t>They allow AI systems to make reasonable inferences based on typical knowledge without requiring exhaustive logical deduction for every detail.</a:t>
+              <a:t>Expert Systems (ES) are computer programs designed to emulate the decision-making ability of a human expert in a specific domain.</a:t>
+            </a:r>
+          </a:p>
+          <a:p>
+            <a:r>
+              <a:t>They were among the first truly successful applications of AI, emerging prominently in the 1970s and 1980s.</a:t>
+            </a:r>
+          </a:p>
+          <a:p>
+            <a:r>
+              <a:t>The core idea is to capture, store, and apply knowledge from human experts to solve complex problems that typically require human intelligence.</a:t>
+            </a:r>
+          </a:p>
+          <a:p>
+            <a:r>
+              <a:t>ES are particularly useful in domains where human expertise is scarce, expensive, or needed quickly and consistently.</a:t>
+            </a:r>
+          </a:p>
+          <a:p>
+            <a:r>
+              <a:t>Early examples include MYCIN (medical diagnosis) and DENDRAL (chemical structure identification).</a:t>
             </a:r>
           </a:p>
         </p:txBody>
@@ -4274,7 +4308,7 @@
           <a:lstStyle/>
           <a:p>
             <a:r>
-              <a:t>Expert Systems: Emulating Human Expertise</a:t>
+              <a:t>Architecture of Expert Systems</a:t>
             </a:r>
           </a:p>
         </p:txBody>
@@ -4295,27 +4329,32 @@
           <a:lstStyle/>
           <a:p>
             <a:r>
-              <a:t>Expert Systems (ES) are AI programs designed to emulate the decision-making ability of a human expert in a specific domain.</a:t>
-            </a:r>
-          </a:p>
-          <a:p>
-            <a:r>
-              <a:t>They leverage a vast amount of domain-specific knowledge, often heuristic, to solve complex problems.</a:t>
-            </a:r>
-          </a:p>
-          <a:p>
-            <a:r>
-              <a:t>Unlike conventional programs, ES separate knowledge from control, making them flexible and easier to update.</a:t>
-            </a:r>
-          </a:p>
-          <a:p>
-            <a:r>
-              <a:t>Early ES, like MYCIN for medical diagnosis, demonstrated significant success in their narrow domains.</a:t>
-            </a:r>
-          </a:p>
-          <a:p>
-            <a:r>
-              <a:t>They aim to provide advice, explanations, and justifications, making their reasoning transparent to the user.</a:t>
+              <a:t>A typical Expert System consists of several key components: Knowledge Base, Inference Engine, Working Memory, User Interface, Explanation Module, and Knowledge Acquisition Module.</a:t>
+            </a:r>
+          </a:p>
+          <a:p>
+            <a:r>
+              <a:t>Knowledge Base: Contains domain-specific facts and rules acquired from human experts, forming the 'brain' of the ES.</a:t>
+            </a:r>
+          </a:p>
+          <a:p>
+            <a:r>
+              <a:t>Inference Engine: The reasoning mechanism that processes the knowledge base to draw conclusions or make decisions by applying rules to facts.</a:t>
+            </a:r>
+          </a:p>
+          <a:p>
+            <a:r>
+              <a:t>Working Memory (Fact Base): Temporary storage for facts specific to the current problem instance, including initial data and inferred conclusions.</a:t>
+            </a:r>
+          </a:p>
+          <a:p>
+            <a:r>
+              <a:t>User Interface: Provides a means for the user to interact with the system, input data, and receive explanations.</a:t>
+            </a:r>
+          </a:p>
+          <a:p>
+            <a:r>
+              <a:t>Explanation Module: Justifies the system's reasoning process and conclusions, enhancing transparency and trustworthiness.</a:t>
             </a:r>
           </a:p>
         </p:txBody>
@@ -4354,7 +4393,7 @@
           <a:lstStyle/>
           <a:p>
             <a:r>
-              <a:t>Architecture of an Expert System</a:t>
+              <a:t>Knowledge Representation in Expert Systems</a:t>
             </a:r>
           </a:p>
         </p:txBody>
@@ -4375,27 +4414,32 @@
           <a:lstStyle/>
           <a:p>
             <a:r>
-              <a:t>Knowledge Base: Contains facts, rules, and heuristics about the domain, typically expressed as IF-THEN rules.</a:t>
-            </a:r>
-          </a:p>
-          <a:p>
-            <a:r>
-              <a:t>Inference Engine: The 'brain' that processes the knowledge base and makes deductions or provides recommendations.</a:t>
-            </a:r>
-          </a:p>
-          <a:p>
-            <a:r>
-              <a:t>Working Memory/Blackboard: Stores facts about the current problem instance, gathered from the user or sensors.</a:t>
-            </a:r>
-          </a:p>
-          <a:p>
-            <a:r>
-              <a:t>User Interface: Facilitates communication between the user and the expert system, often including explanation facilities.</a:t>
-            </a:r>
-          </a:p>
-          <a:p>
-            <a:r>
-              <a:t>Knowledge Acquisition Subsystem: Tools and methods used to elicit, formalize, and store knowledge from human experts.</a:t>
+              <a:t>The primary challenge in building an ES is the 'knowledge acquisition bottleneck': extracting, formalizing, and representing expert knowledge.</a:t>
+            </a:r>
+          </a:p>
+          <a:p>
+            <a:r>
+              <a:t>Production Rules (If-Then Rules): The most common form of knowledge representation, connecting conditions (antecedents) to actions or conclusions (consequents).</a:t>
+            </a:r>
+          </a:p>
+          <a:p>
+            <a:r>
+              <a:t>Example Rule: IF (symptom is fever) AND (symptom is cough) THEN (diagnosis is flu).</a:t>
+            </a:r>
+          </a:p>
+          <a:p>
+            <a:r>
+              <a:t>Semantic Networks and Frames: Also used, especially for representing hierarchical or categorical knowledge and relationships between concepts.</a:t>
+            </a:r>
+          </a:p>
+          <a:p>
+            <a:r>
+              <a:t>Objects and Attributes: In some systems, knowledge is represented using object-attribute-value triples.</a:t>
+            </a:r>
+          </a:p>
+          <a:p>
+            <a:r>
+              <a:t>The choice of representation depends on the domain, type of expertise, and the intended inference mechanism, being critical for accurate and efficient reasoning.</a:t>
             </a:r>
           </a:p>
         </p:txBody>
@@ -4434,7 +4478,7 @@
           <a:lstStyle/>
           <a:p>
             <a:r>
-              <a:t>Knowledge Acquisition and Representation in ES</a:t>
+              <a:t>Inference Engines: Forward and Backward Chaining</a:t>
             </a:r>
           </a:p>
         </p:txBody>
@@ -4455,27 +4499,32 @@
           <a:lstStyle/>
           <a:p>
             <a:r>
-              <a:t>Knowledge acquisition is the process of extracting, structuring, and organizing knowledge from human experts.</a:t>
-            </a:r>
-          </a:p>
-          <a:p>
-            <a:r>
-              <a:t>This often involves interviews, observation, and analysis of case studies by a 'knowledge engineer'.</a:t>
-            </a:r>
-          </a:p>
-          <a:p>
-            <a:r>
-              <a:t>Representation typically uses production rules (IF-THEN statements) due to their modularity and expressiveness for heuristic knowledge.</a:t>
-            </a:r>
-          </a:p>
-          <a:p>
-            <a:r>
-              <a:t>Example: IF (patient has fever) AND (patient has cough) THEN (patient might have flu).</a:t>
-            </a:r>
-          </a:p>
-          <a:p>
-            <a:r>
-              <a:t>Other representation methods like semantic networks and frames can also be integrated for richer knowledge models.</a:t>
+              <a:t>The Inference Engine is the active component that applies knowledge from the knowledge base to the problem facts in working memory.</a:t>
+            </a:r>
+          </a:p>
+          <a:p>
+            <a:r>
+              <a:t>Forward Chaining (Data-Driven): Starts with known facts and applies rules to deduce new facts until a goal is reached. Suitable when all initial data is available (e.g., medical diagnosis from symptoms).</a:t>
+            </a:r>
+          </a:p>
+          <a:p>
+            <a:r>
+              <a:t>Process: Match facts to the 'IF' parts of rules, fire matching rules, add conclusions to working memory, repeating until no more rules can fire or goal is met.</a:t>
+            </a:r>
+          </a:p>
+          <a:p>
+            <a:r>
+              <a:t>Backward Chaining (Goal-Driven): Starts with a potential goal or hypothesis and works backward to find facts or sub-goals that support it. Suitable for verifying specific queries (e.g., configuration systems).</a:t>
+            </a:r>
+          </a:p>
+          <a:p>
+            <a:r>
+              <a:t>Process: Try to prove a goal. If it's a rule's 'THEN' part, check if its 'IF' parts are true; if not, set them as new sub-goals.</a:t>
+            </a:r>
+          </a:p>
+          <a:p>
+            <a:r>
+              <a:t>Many expert systems combine both approaches, using forward chaining for initial data and backward chaining for specific goal pursuit.</a:t>
             </a:r>
           </a:p>
         </p:txBody>
@@ -4514,7 +4563,7 @@
           <a:lstStyle/>
           <a:p>
             <a:r>
-              <a:t>Inference Engines: Forward and Backward Chaining</a:t>
+              <a:t>Challenges and Applications of Expert Systems</a:t>
             </a:r>
           </a:p>
         </p:txBody>
@@ -4535,27 +4584,27 @@
           <a:lstStyle/>
           <a:p>
             <a:r>
-              <a:t>The inference engine determines how the ES uses its knowledge to reach conclusions.</a:t>
-            </a:r>
-          </a:p>
-          <a:p>
-            <a:r>
-              <a:t>Forward Chaining (data-driven): Starts with known facts in the working memory and applies rules to deduce new facts.</a:t>
-            </a:r>
-          </a:p>
-          <a:p>
-            <a:r>
-              <a:t>It proceeds until no more rules can be fired or a goal is reached; suitable for prediction or monitoring.</a:t>
-            </a:r>
-          </a:p>
-          <a:p>
-            <a:r>
-              <a:t>Backward Chaining (goal-driven): Starts with a hypothetical conclusion (goal) and works backward to find facts that support it.</a:t>
-            </a:r>
-          </a:p>
-          <a:p>
-            <a:r>
-              <a:t>It queries the user for unknown facts if needed; suitable for diagnosis or recommendation tasks.</a:t>
+              <a:t>Challenges: Knowledge acquisition bottleneck, brittleness (limited to narrow domains), high maintenance for knowledge updates, scalability issues, and validation difficulties.</a:t>
+            </a:r>
+          </a:p>
+          <a:p>
+            <a:r>
+              <a:t>Brittleness: ES often lack common sense reasoning and perform poorly outside their precisely defined scope.</a:t>
+            </a:r>
+          </a:p>
+          <a:p>
+            <a:r>
+              <a:t>Applications: Medical diagnosis (MYCIN), financial planning, configuring complex computer systems (XCON), process control, and early fraud detection.</a:t>
+            </a:r>
+          </a:p>
+          <a:p>
+            <a:r>
+              <a:t>Further Applications: Quality control in manufacturing, and various diagnostic tasks.</a:t>
+            </a:r>
+          </a:p>
+          <a:p>
+            <a:r>
+              <a:t>While direct 'expert systems' diminished with the rise of ML, their principles of knowledge representation and rule-based reasoning remain influential, especially where explainability is paramount.</a:t>
             </a:r>
           </a:p>
         </p:txBody>
@@ -4594,7 +4643,7 @@
           <a:lstStyle/>
           <a:p>
             <a:r>
-              <a:t>Applications and Limitations of Expert Systems</a:t>
+              <a:t>What is Machine Learning?</a:t>
             </a:r>
           </a:p>
         </p:txBody>
@@ -4615,27 +4664,27 @@
           <a:lstStyle/>
           <a:p>
             <a:r>
-              <a:t>Applications: Medical diagnosis (MYCIN), financial planning, fault detection, configuration (R1/XCON), scheduling, and process control.</a:t>
-            </a:r>
-          </a:p>
-          <a:p>
-            <a:r>
-              <a:t>ES are particularly valuable in domains where human expertise is scarce or needs to be widely distributed.</a:t>
-            </a:r>
-          </a:p>
-          <a:p>
-            <a:r>
-              <a:t>Limitations: Knowledge acquisition is a bottleneck, as eliciting expert knowledge is time-consuming and difficult.</a:t>
-            </a:r>
-          </a:p>
-          <a:p>
-            <a:r>
-              <a:t>Brittleness: ES perform poorly outside their specific domain of expertise; they lack common sense reasoning.</a:t>
-            </a:r>
-          </a:p>
-          <a:p>
-            <a:r>
-              <a:t>Maintenance: Keeping the knowledge base updated and consistent can be challenging and costly over time.</a:t>
+              <a:t>Machine Learning (ML) is a subset of Artificial Intelligence (AI) that enables systems to learn from data without being explicitly programmed.</a:t>
+            </a:r>
+          </a:p>
+          <a:p>
+            <a:r>
+              <a:t>Arthur Samuel defined ML in 1959 as a 'field of study that gives computers the ability to learn without being explicitly programmed.'</a:t>
+            </a:r>
+          </a:p>
+          <a:p>
+            <a:r>
+              <a:t>Instead of hardcoding rules, ML algorithms identify patterns and make predictions or decisions based on observed data.</a:t>
+            </a:r>
+          </a:p>
+          <a:p>
+            <a:r>
+              <a:t>The core idea is to build models that can generalize from examples, improving their performance on a specific task over time with more data.</a:t>
+            </a:r>
+          </a:p>
+          <a:p>
+            <a:r>
+              <a:t>ML has become a transformative technology, driving innovation across various industries, from healthcare to finance and autonomous systems.</a:t>
             </a:r>
           </a:p>
         </p:txBody>
@@ -4674,7 +4723,7 @@
           <a:lstStyle/>
           <a:p>
             <a:r>
-              <a:t>Introduction to Machine Learning: A New Paradigm</a:t>
+              <a:t>AI, ML, DL Relationship</a:t>
             </a:r>
           </a:p>
         </p:txBody>
@@ -4695,27 +4744,27 @@
           <a:lstStyle/>
           <a:p>
             <a:r>
-              <a:t>Machine Learning (ML) is a subfield of AI focused on enabling systems to learn from data without explicit programming.</a:t>
-            </a:r>
-          </a:p>
-          <a:p>
-            <a:r>
-              <a:t>Instead of rules explicitly encoded by humans, ML models learn patterns and make decisions or predictions.</a:t>
-            </a:r>
-          </a:p>
-          <a:p>
-            <a:r>
-              <a:t>This paradigm shift allows AI systems to adapt, generalize, and perform tasks in complex, dynamic environments.</a:t>
-            </a:r>
-          </a:p>
-          <a:p>
-            <a:r>
-              <a:t>ML algorithms build a mathematical model based on sample data, known as 'training data', to make predictions or decisions.</a:t>
-            </a:r>
-          </a:p>
-          <a:p>
-            <a:r>
-              <a:t>It has become pervasive, powering applications from search engines and recommendation systems to medical diagnosis and autonomous vehicles.</a:t>
+              <a:t>Artificial Intelligence (AI): The broadest field, encompassing any technique that enables computers to mimic human intelligence, including logic, expert systems, planning, and perception.</a:t>
+            </a:r>
+          </a:p>
+          <a:p>
+            <a:r>
+              <a:t>Machine Learning (ML): A subfield of AI focused on algorithms that allow systems to learn from data and improve performance on a task without explicit programming; it's a method of achieving AI.</a:t>
+            </a:r>
+          </a:p>
+          <a:p>
+            <a:r>
+              <a:t>Deep Learning (DL): A subfield of Machine Learning that uses artificial neural networks with multiple layers ('deep') to learn representations of data with multiple levels of abstraction.</a:t>
+            </a:r>
+          </a:p>
+          <a:p>
+            <a:r>
+              <a:t>DL has significantly advanced ML capabilities in areas like image recognition, natural language processing, and speech recognition due to its ability to automatically learn complex features.</a:t>
+            </a:r>
+          </a:p>
+          <a:p>
+            <a:r>
+              <a:t>Essentially, AI is the umbrella concept, ML is a specific approach to AI, and DL is a powerful sub-approach within ML.</a:t>
             </a:r>
           </a:p>
         </p:txBody>
@@ -4754,7 +4803,7 @@
           <a:lstStyle/>
           <a:p>
             <a:r>
-              <a:t>What is Machine Learning? Core Concepts</a:t>
+              <a:t>Types of Machine Learning Tasks</a:t>
             </a:r>
           </a:p>
         </p:txBody>
@@ -4775,27 +4824,27 @@
           <a:lstStyle/>
           <a:p>
             <a:r>
-              <a:t>At its core, ML is about creating algorithms that can 'learn' from data to perform a task.</a:t>
-            </a:r>
-          </a:p>
-          <a:p>
-            <a:r>
-              <a:t>Learning here refers to optimizing a performance criterion using example data or past experiences.</a:t>
-            </a:r>
-          </a:p>
-          <a:p>
-            <a:r>
-              <a:t>A computer program is said to learn from experience E with respect to some class of tasks T and performance measure P if its performance at tasks in T, as measured by P, improves with experience E (Tom Mitchell).</a:t>
-            </a:r>
-          </a:p>
-          <a:p>
-            <a:r>
-              <a:t>Key elements include Data (input for learning), Model (the learned representation), and Algorithm (the learning process itself).</a:t>
-            </a:r>
-          </a:p>
-          <a:p>
-            <a:r>
-              <a:t>The goal is often generalization: the ability of a model to perform well on unseen data after training.</a:t>
+              <a:t>Machine learning tasks can be broadly categorized based on the nature of the learning signal or feedback available.</a:t>
+            </a:r>
+          </a:p>
+          <a:p>
+            <a:r>
+              <a:t>Supervised Learning: Learning from labeled data (input-output pairs), used for prediction and classification (e.g., predicting house prices, classifying emails).</a:t>
+            </a:r>
+          </a:p>
+          <a:p>
+            <a:r>
+              <a:t>Unsupervised Learning: Learning from unlabeled data to identify hidden patterns or structures (e.g., clustering customers, dimensionality reduction).</a:t>
+            </a:r>
+          </a:p>
+          <a:p>
+            <a:r>
+              <a:t>Reinforcement Learning: Learning through trial and error by interacting with an environment to maximize cumulative reward (e.g., training autonomous agents).</a:t>
+            </a:r>
+          </a:p>
+          <a:p>
+            <a:r>
+              <a:t>Semi-Supervised Learning: A hybrid approach using a small amount of labeled data and a large amount of unlabeled data to improve learning efficiency and accuracy.</a:t>
             </a:r>
           </a:p>
         </p:txBody>
@@ -4834,7 +4883,7 @@
           <a:lstStyle/>
           <a:p>
             <a:r>
-              <a:t>Types of Machine Learning Problems</a:t>
+              <a:t>Core Components of an ML System</a:t>
             </a:r>
           </a:p>
         </p:txBody>
@@ -4855,27 +4904,32 @@
           <a:lstStyle/>
           <a:p>
             <a:r>
-              <a:t>Supervised Learning: Learning from labeled data, where the model is given input-output pairs (e.g., classification, regression).</a:t>
-            </a:r>
-          </a:p>
-          <a:p>
-            <a:r>
-              <a:t>Unsupervised Learning: Discovering patterns in unlabeled data, without explicit target outputs (e.g., clustering, dimensionality reduction).</a:t>
-            </a:r>
-          </a:p>
-          <a:p>
-            <a:r>
-              <a:t>Reinforcement Learning: Learning through interaction with an environment, receiving rewards or penalties for actions (e.g., game playing, robotics).</a:t>
-            </a:r>
-          </a:p>
-          <a:p>
-            <a:r>
-              <a:t>Semi-supervised Learning: Combines small amounts of labeled data with large amounts of unlabeled data for training.</a:t>
-            </a:r>
-          </a:p>
-          <a:p>
-            <a:r>
-              <a:t>Self-supervised Learning: A form of unsupervised learning where the data provides its own supervision signal.</a:t>
+              <a:t>A typical Machine Learning system comprises several interconnected components: Data, Features, Model, Learning Algorithm, Objective Function, and Parameters.</a:t>
+            </a:r>
+          </a:p>
+          <a:p>
+            <a:r>
+              <a:t>Data: The raw information from which the model learns; its quality and quantity are paramount.</a:t>
+            </a:r>
+          </a:p>
+          <a:p>
+            <a:r>
+              <a:t>Features: Relevant attributes extracted from raw data, used as input to the model. Feature engineering is a critical step.</a:t>
+            </a:r>
+          </a:p>
+          <a:p>
+            <a:r>
+              <a:t>Model: The algorithm or mathematical structure (e.g., neural network, decision tree) that learns patterns from the data.</a:t>
+            </a:r>
+          </a:p>
+          <a:p>
+            <a:r>
+              <a:t>Learning Algorithm: The process by which the model adjusts its internal parameters based on training data and an objective function.</a:t>
+            </a:r>
+          </a:p>
+          <a:p>
+            <a:r>
+              <a:t>Objective Function (Loss/Cost Function): Quantifies the difference between predictions and actual targets, guiding the learning process to minimize error.</a:t>
             </a:r>
           </a:p>
         </p:txBody>
@@ -4914,7 +4968,7 @@
           <a:lstStyle/>
           <a:p>
             <a:r>
-              <a:t>Propositional Logic: Basic Concepts</a:t>
+              <a:t>Truth Tables and Logical Equivalences</a:t>
             </a:r>
           </a:p>
         </p:txBody>
@@ -4935,27 +4989,27 @@
           <a:lstStyle/>
           <a:p>
             <a:r>
-              <a:t>Propositional logic (PL) is the simplest form of logic, dealing with statements that are either true or false.</a:t>
-            </a:r>
-          </a:p>
-          <a:p>
-            <a:r>
-              <a:t>Atomic propositions are basic declarative sentences (e.g., 'It is raining'), represented by symbols (P, Q, R).</a:t>
-            </a:r>
-          </a:p>
-          <a:p>
-            <a:r>
-              <a:t>Compound propositions are formed by connecting atomic propositions using logical connectives.</a:t>
-            </a:r>
-          </a:p>
-          <a:p>
-            <a:r>
-              <a:t>Key connectives include AND (∧), OR (∨), NOT (¬), IMPLIES (→), and EQUIVALENCE (↔).</a:t>
-            </a:r>
-          </a:p>
-          <a:p>
-            <a:r>
-              <a:t>Truth tables are used to define the semantics of these connectives and determine the truth value of complex statements.</a:t>
+              <a:t>A truth table systematically lists all possible truth assignments for propositional variables and the resulting truth values for a compound proposition.</a:t>
+            </a:r>
+          </a:p>
+          <a:p>
+            <a:r>
+              <a:t>Truth tables are essential for determining the validity of arguments, identifying tautologies (always true), contradictions (always false), and contingencies.</a:t>
+            </a:r>
+          </a:p>
+          <a:p>
+            <a:r>
+              <a:t>Logical equivalence means two propositions have the same truth value for all possible truth assignments of their variables, denoted by P ≡ Q.</a:t>
+            </a:r>
+          </a:p>
+          <a:p>
+            <a:r>
+              <a:t>Key equivalences include De Morgan's Laws (¬(P∧Q) ≡ ¬P∨¬Q), distributive laws, and the definition of implication (P→Q ≡ ¬P∨Q).</a:t>
+            </a:r>
+          </a:p>
+          <a:p>
+            <a:r>
+              <a:t>Understanding logical equivalences is crucial for simplifying logical expressions, proving theorems, and transforming knowledge representations.</a:t>
             </a:r>
           </a:p>
         </p:txBody>
@@ -4994,7 +5048,7 @@
           <a:lstStyle/>
           <a:p>
             <a:r>
-              <a:t>The Machine Learning Workflow</a:t>
+              <a:t>Data in Machine Learning: Importance and Types</a:t>
             </a:r>
           </a:p>
         </p:txBody>
@@ -5015,27 +5069,32 @@
           <a:lstStyle/>
           <a:p>
             <a:r>
-              <a:t>Problem Definition: Clearly define the task, objectives, and available data.</a:t>
-            </a:r>
-          </a:p>
-          <a:p>
-            <a:r>
-              <a:t>Data Collection &amp; Preprocessing: Gather relevant data, clean it, handle missing values, and prepare it for model training.</a:t>
-            </a:r>
-          </a:p>
-          <a:p>
-            <a:r>
-              <a:t>Feature Engineering: Selecting, transforming, or creating relevant features from raw data to improve model performance.</a:t>
-            </a:r>
-          </a:p>
-          <a:p>
-            <a:r>
-              <a:t>Model Selection &amp; Training: Choose an appropriate ML algorithm and train it on the prepared data.</a:t>
-            </a:r>
-          </a:p>
-          <a:p>
-            <a:r>
-              <a:t>Model Evaluation &amp; Deployment: Assess the model's performance using metrics and deploy it for real-world use.</a:t>
+              <a:t>Data is the fuel for machine learning; its quality, quantity, and relevance directly impact model performance – 'Garbage in, garbage out' is critically true.</a:t>
+            </a:r>
+          </a:p>
+          <a:p>
+            <a:r>
+              <a:t>Structured Data: Organized into tabular format (rows, columns), easily stored and processed in databases (e.g., CSV, SQL). Common in business applications.</a:t>
+            </a:r>
+          </a:p>
+          <a:p>
+            <a:r>
+              <a:t>Unstructured Data: Lacks predefined format, often textual or multimedia (e.g., emails, images, audio). Requires advanced processing techniques.</a:t>
+            </a:r>
+          </a:p>
+          <a:p>
+            <a:r>
+              <a:t>Semi-structured Data: Contains tags or markers for hierarchical grouping but without rigid relational schema (e.g., XML, JSON).</a:t>
+            </a:r>
+          </a:p>
+          <a:p>
+            <a:r>
+              <a:t>Data Preprocessing: Crucial steps before training, including cleaning (handling missing values, removing noise), transformation (scaling, normalization), and feature engineering (creating new features).</a:t>
+            </a:r>
+          </a:p>
+          <a:p>
+            <a:r>
+              <a:t>Proper data management and preprocessing are often the most time-consuming yet critical parts of an ML project.</a:t>
             </a:r>
           </a:p>
         </p:txBody>
@@ -5074,7 +5133,7 @@
           <a:lstStyle/>
           <a:p>
             <a:r>
-              <a:t>Key Components: Data, Model, Learning Algorithm</a:t>
+              <a:t>Introduction to Supervised Learning</a:t>
             </a:r>
           </a:p>
         </p:txBody>
@@ -5095,32 +5154,27 @@
           <a:lstStyle/>
           <a:p>
             <a:r>
-              <a:t>Data: The raw material for machine learning, consisting of observations, measurements, or instances.</a:t>
-            </a:r>
-          </a:p>
-          <a:p>
-            <a:r>
-              <a:t>It typically includes features (input variables) and, for supervised tasks, labels (target output variables).</a:t>
-            </a:r>
-          </a:p>
-          <a:p>
-            <a:r>
-              <a:t>Model: The mathematical representation learned from the data, which captures underlying patterns and relationships.</a:t>
-            </a:r>
-          </a:p>
-          <a:p>
-            <a:r>
-              <a:t>It can be a set of weights in a neural network, splits in a decision tree, or parameters in a regression equation.</a:t>
-            </a:r>
-          </a:p>
-          <a:p>
-            <a:r>
-              <a:t>Learning Algorithm: The computational procedure that processes the data to build or adjust the model.</a:t>
-            </a:r>
-          </a:p>
-          <a:p>
-            <a:r>
-              <a:t>It often involves optimization techniques to minimize an error function or maximize a performance metric.</a:t>
+              <a:t>Supervised learning is a paradigm in machine learning where an algorithm learns from a labeled dataset.</a:t>
+            </a:r>
+          </a:p>
+          <a:p>
+            <a:r>
+              <a:t>The dataset consists of input-output pairs (X, Y), where X represents the input features and Y is the corresponding desired output or 'label.'</a:t>
+            </a:r>
+          </a:p>
+          <a:p>
+            <a:r>
+              <a:t>The goal is to learn a mapping function from the input features to the output labels, such that the model can accurately predict outputs for new, unseen inputs.</a:t>
+            </a:r>
+          </a:p>
+          <a:p>
+            <a:r>
+              <a:t>The learning process involves minimizing the difference between the model's predictions and the true labels over the training data using an objective function.</a:t>
+            </a:r>
+          </a:p>
+          <a:p>
+            <a:r>
+              <a:t>It's called 'supervised' because the presence of labels acts as a supervisor, guiding the learning process by providing the correct answers for each example.</a:t>
             </a:r>
           </a:p>
         </p:txBody>
@@ -5159,7 +5213,7 @@
           <a:lstStyle/>
           <a:p>
             <a:r>
-              <a:t>Supervised Learning: Learning from Labeled Data</a:t>
+              <a:t>Key Concepts: Features, Labels, Training Data</a:t>
             </a:r>
           </a:p>
         </p:txBody>
@@ -5180,27 +5234,32 @@
           <a:lstStyle/>
           <a:p>
             <a:r>
-              <a:t>Supervised learning is a paradigm where an algorithm learns a mapping from input features to output labels.</a:t>
-            </a:r>
-          </a:p>
-          <a:p>
-            <a:r>
-              <a:t>It requires a dataset where each input instance is explicitly paired with its correct output or 'ground truth'.</a:t>
-            </a:r>
-          </a:p>
-          <a:p>
-            <a:r>
-              <a:t>The algorithm's goal is to learn a general rule that maps inputs to outputs, which can then predict outputs for new, unseen inputs.</a:t>
-            </a:r>
-          </a:p>
-          <a:p>
-            <a:r>
-              <a:t>This process is akin to a student learning under the guidance of a 'supervisor' who provides correct answers.</a:t>
-            </a:r>
-          </a:p>
-          <a:p>
-            <a:r>
-              <a:t>Common applications include image classification, spam detection, medical diagnosis, and predicting house prices.</a:t>
+              <a:t>Features (X): Independent variables or attributes of the data used as input to the model, representing characteristics of each data point (e.g., square footage, number of bedrooms for house price prediction).</a:t>
+            </a:r>
+          </a:p>
+          <a:p>
+            <a:r>
+              <a:t>Labels (Y): Dependent variables or target outputs that the model is trained to predict; these are the 'correct answers' in the training data (e.g., actual selling price, 'spam'/'not spam').</a:t>
+            </a:r>
+          </a:p>
+          <a:p>
+            <a:r>
+              <a:t>Training Data: The subset of the complete dataset used to train the machine learning model, consisting of many (X, Y) pairs from which the model learns the relationship.</a:t>
+            </a:r>
+          </a:p>
+          <a:p>
+            <a:r>
+              <a:t>Validation Data: A separate subset of data used to tune hyperparameters and evaluate the model's performance during training, helping to prevent overfitting.</a:t>
+            </a:r>
+          </a:p>
+          <a:p>
+            <a:r>
+              <a:t>Test Data: An entirely unseen subset of data used to assess the final trained model's generalization ability on new, real-world data, providing an unbiased evaluation.</a:t>
+            </a:r>
+          </a:p>
+          <a:p>
+            <a:r>
+              <a:t>Proper division into these sets is crucial for robust model development and evaluation.</a:t>
             </a:r>
           </a:p>
         </p:txBody>
@@ -5239,7 +5298,7 @@
           <a:lstStyle/>
           <a:p>
             <a:r>
-              <a:t>Labeled Data and Feature Engineering</a:t>
+              <a:t>Regression Problems: Predicting Continuous Values</a:t>
             </a:r>
           </a:p>
         </p:txBody>
@@ -5260,27 +5319,32 @@
           <a:lstStyle/>
           <a:p>
             <a:r>
-              <a:t>Labeled data consists of input-output pairs (x, y), where 'x' represents input features and 'y' is the corresponding label.</a:t>
-            </a:r>
-          </a:p>
-          <a:p>
-            <a:r>
-              <a:t>Labels are crucial; they provide the target variable the model aims to predict or classify.</a:t>
-            </a:r>
-          </a:p>
-          <a:p>
-            <a:r>
-              <a:t>Features are individual measurable properties or characteristics of the phenomenon being observed.</a:t>
-            </a:r>
-          </a:p>
-          <a:p>
-            <a:r>
-              <a:t>Feature engineering is the process of selecting, transforming, or creating new features from raw data.</a:t>
-            </a:r>
-          </a:p>
-          <a:p>
-            <a:r>
-              <a:t>Effective feature engineering significantly impacts model performance and is often more critical than algorithm choice.</a:t>
+              <a:t>Regression is a type of supervised learning task where the goal is to predict a continuous numerical output value.</a:t>
+            </a:r>
+          </a:p>
+          <a:p>
+            <a:r>
+              <a:t>The output variable can take any value within a range, making it suitable for predicting quantities, rather than discrete categories.</a:t>
+            </a:r>
+          </a:p>
+          <a:p>
+            <a:r>
+              <a:t>Examples include predicting house prices, stock market fluctuations, temperature, age, or sales figures.</a:t>
+            </a:r>
+          </a:p>
+          <a:p>
+            <a:r>
+              <a:t>The model learns to estimate the functional relationship between the input features and the continuous target variable, often aiming to minimize a cost function like squared error.</a:t>
+            </a:r>
+          </a:p>
+          <a:p>
+            <a:r>
+              <a:t>Common regression algorithms include Linear Regression, Polynomial Regression, Decision Tree Regression, Support Vector Regression (SVR), and ensemble methods like Random Forest Regressor.</a:t>
+            </a:r>
+          </a:p>
+          <a:p>
+            <a:r>
+              <a:t>Performance is typically measured using metrics like Mean Squared Error (MSE), Root Mean Squared Error (RMSE), or R-squared.</a:t>
             </a:r>
           </a:p>
         </p:txBody>
@@ -5319,7 +5383,7 @@
           <a:lstStyle/>
           <a:p>
             <a:r>
-              <a:t>Common Supervised Learning Tasks</a:t>
+              <a:t>Classification Problems: Predicting Discrete Categories</a:t>
             </a:r>
           </a:p>
         </p:txBody>
@@ -5340,27 +5404,32 @@
           <a:lstStyle/>
           <a:p>
             <a:r>
-              <a:t>Classification: Predicting a discrete class label (e.g., spam/not spam, disease A/B/C, cat/dog).</a:t>
-            </a:r>
-          </a:p>
-          <a:p>
-            <a:r>
-              <a:t>The output is a categorical value, choosing one from a predefined set of categories.</a:t>
-            </a:r>
-          </a:p>
-          <a:p>
-            <a:r>
-              <a:t>Regression: Predicting a continuous numerical value (e.g., house prices, temperature, stock values).</a:t>
-            </a:r>
-          </a:p>
-          <a:p>
-            <a:r>
-              <a:t>The output is a real number, allowing for predictions along a continuous spectrum.</a:t>
-            </a:r>
-          </a:p>
-          <a:p>
-            <a:r>
-              <a:t>Other tasks include object detection, semantic segmentation, and sequence-to-sequence prediction.</a:t>
+              <a:t>Classification is another type of supervised learning task where the goal is to predict a discrete categorical output label.</a:t>
+            </a:r>
+          </a:p>
+          <a:p>
+            <a:r>
+              <a:t>The output variable belongs to a finite set of predefined categories or classes, unlike continuous values in regression.</a:t>
+            </a:r>
+          </a:p>
+          <a:p>
+            <a:r>
+              <a:t>Binary Classification: Predicts one of two classes (e.g., spam/not spam, disease/no disease). This is the simplest form.</a:t>
+            </a:r>
+          </a:p>
+          <a:p>
+            <a:r>
+              <a:t>Multi-class Classification: Predicts one of more than two classes (e.g., types of animals, handwritten digit recognition, sentiment analysis into positive/negative/neutral).</a:t>
+            </a:r>
+          </a:p>
+          <a:p>
+            <a:r>
+              <a:t>The model learns to assign an input example to one of the predefined categories based on its features and the patterns learned from the labeled training data.</a:t>
+            </a:r>
+          </a:p>
+          <a:p>
+            <a:r>
+              <a:t>Common classification algorithms include Logistic Regression, K-Nearest Neighbors (K-NN), Support Vector Machines (SVM), Decision Trees, Naive Bayes, and neural networks.</a:t>
             </a:r>
           </a:p>
         </p:txBody>
@@ -5399,7 +5468,7 @@
           <a:lstStyle/>
           <a:p>
             <a:r>
-              <a:t>Examples of Supervised Algorithms</a:t>
+              <a:t>Common Supervised Learning Algorithms Overview</a:t>
             </a:r>
           </a:p>
         </p:txBody>
@@ -5420,27 +5489,32 @@
           <a:lstStyle/>
           <a:p>
             <a:r>
-              <a:t>Linear Regression: A simple model for predicting a continuous output, assuming a linear relationship between features and target.</a:t>
-            </a:r>
-          </a:p>
-          <a:p>
-            <a:r>
-              <a:t>Logistic Regression: Despite its name, used for binary classification, modeling the probability of an event.</a:t>
-            </a:r>
-          </a:p>
-          <a:p>
-            <a:r>
-              <a:t>Decision Trees: Tree-like models where internal nodes represent tests on features, branches represent outcomes, and leaf nodes represent class labels or values.</a:t>
-            </a:r>
-          </a:p>
-          <a:p>
-            <a:r>
-              <a:t>Support Vector Machines (SVMs): Powerful algorithms for classification and regression that find the optimal hyperplane to separate data points.</a:t>
-            </a:r>
-          </a:p>
-          <a:p>
-            <a:r>
-              <a:t>K-Nearest Neighbors (KNN): A non-parametric, instance-based learning algorithm that classifies new data points based on the majority class of their 'k' nearest neighbors.</a:t>
+              <a:t>Linear Regression: A foundational algorithm for regression tasks, modeling the relationship between features and output as a linear equation.</a:t>
+            </a:r>
+          </a:p>
+          <a:p>
+            <a:r>
+              <a:t>Logistic Regression: Primarily used for binary classification, despite its name. It models the probability of a binary outcome using a sigmoid function.</a:t>
+            </a:r>
+          </a:p>
+          <a:p>
+            <a:r>
+              <a:t>Decision Trees: Tree-like models where internal nodes test attributes, branches are outcomes, and leaf nodes represent class labels or regression values; highly interpretable.</a:t>
+            </a:r>
+          </a:p>
+          <a:p>
+            <a:r>
+              <a:t>Support Vector Machines (SVM): Powerful for classification and regression, finding an optimal hyperplane that maximally separates data points of different classes in a high-dimensional space.</a:t>
+            </a:r>
+          </a:p>
+          <a:p>
+            <a:r>
+              <a:t>K-Nearest Neighbors (K-NN): A non-parametric, instance-based learning algorithm that classifies a data point based on the majority class of its 'k' nearest neighbors in the feature space.</a:t>
+            </a:r>
+          </a:p>
+          <a:p>
+            <a:r>
+              <a:t>Random Forests: An ensemble method building multiple decision trees, averaging or voting their predictions to improve accuracy and robustness for both classification and regression.</a:t>
             </a:r>
           </a:p>
         </p:txBody>
@@ -5479,7 +5553,7 @@
           <a:lstStyle/>
           <a:p>
             <a:r>
-              <a:t>Challenges and Considerations in Supervised Learning</a:t>
+              <a:t>Introduction to Unsupervised Learning</a:t>
             </a:r>
           </a:p>
         </p:txBody>
@@ -5500,27 +5574,27 @@
           <a:lstStyle/>
           <a:p>
             <a:r>
-              <a:t>Data Quality: The performance of supervised models is highly dependent on the quality and quantity of labeled training data.</a:t>
-            </a:r>
-          </a:p>
-          <a:p>
-            <a:r>
-              <a:t>Overfitting: When a model learns the training data too well, including noise, leading to poor generalization on unseen data.</a:t>
-            </a:r>
-          </a:p>
-          <a:p>
-            <a:r>
-              <a:t>Underfitting: When a model is too simple to capture the underlying patterns in the data, resulting in high error on both training and test data.</a:t>
-            </a:r>
-          </a:p>
-          <a:p>
-            <a:r>
-              <a:t>Bias-Variance Trade-off: A fundamental concept balancing model complexity against its ability to generalize.</a:t>
-            </a:r>
-          </a:p>
-          <a:p>
-            <a:r>
-              <a:t>Labeling Cost: Acquiring accurately labeled data can be expensive and time-consuming, especially for large datasets.</a:t>
+              <a:t>Unsupervised learning is a machine learning paradigm where algorithms learn from unlabeled data, meaning there are no predefined output labels or target variables.</a:t>
+            </a:r>
+          </a:p>
+          <a:p>
+            <a:r>
+              <a:t>The primary goal is to discover hidden patterns, structures, or relationships within the data itself without explicit guidance.</a:t>
+            </a:r>
+          </a:p>
+          <a:p>
+            <a:r>
+              <a:t>Instead of predicting an output, unsupervised algorithms aim to understand the underlying distribution of the data or to group similar data points together.</a:t>
+            </a:r>
+          </a:p>
+          <a:p>
+            <a:r>
+              <a:t>It's called 'unsupervised' because there's no 'supervisor' providing correct answers; the algorithm must find its own structure from the input features.</a:t>
+            </a:r>
+          </a:p>
+          <a:p>
+            <a:r>
+              <a:t>Unsupervised learning is crucial for exploratory data analysis, data compression, feature learning, and anomaly detection.</a:t>
             </a:r>
           </a:p>
         </p:txBody>
@@ -5559,7 +5633,7 @@
           <a:lstStyle/>
           <a:p>
             <a:r>
-              <a:t>Unsupervised Learning: Discovering Hidden Patterns</a:t>
+              <a:t>Clustering: Grouping Similar Data Points</a:t>
             </a:r>
           </a:p>
         </p:txBody>
@@ -5580,27 +5654,27 @@
           <a:lstStyle/>
           <a:p>
             <a:r>
-              <a:t>Unsupervised learning deals with unlabeled data, where there are no explicit output labels or target variables.</a:t>
-            </a:r>
-          </a:p>
-          <a:p>
-            <a:r>
-              <a:t>The primary goal is to discover hidden structures, patterns, or relationships within the input data itself.</a:t>
-            </a:r>
-          </a:p>
-          <a:p>
-            <a:r>
-              <a:t>It aims to understand the intrinsic organization of the data without external guidance or prior knowledge of outcomes.</a:t>
-            </a:r>
-          </a:p>
-          <a:p>
-            <a:r>
-              <a:t>This approach is particularly useful when labels are unavailable, difficult, or expensive to obtain.</a:t>
-            </a:r>
-          </a:p>
-          <a:p>
-            <a:r>
-              <a:t>Applications include customer segmentation, anomaly detection, data compression, and feature learning.</a:t>
+              <a:t>Clustering is a fundamental unsupervised learning task that aims to partition a dataset into groups (clusters) such that data points within the same group are more similar to each other than to those in other groups.</a:t>
+            </a:r>
+          </a:p>
+          <a:p>
+            <a:r>
+              <a:t>Similarity is often measured using distance metrics (e.g., Euclidean distance, cosine similarity) in the feature space, defining proximity between data points.</a:t>
+            </a:r>
+          </a:p>
+          <a:p>
+            <a:r>
+              <a:t>The number of clusters can be pre-defined by the user (as in K-Means) or discovered by the algorithm itself (as in hierarchical or density-based methods).</a:t>
+            </a:r>
+          </a:p>
+          <a:p>
+            <a:r>
+              <a:t>Common clustering algorithms include: K-Means (partitions data into k clusters based on centroids), Hierarchical Clustering (builds a tree of clusters), and DBSCAN (identifies density-connected points).</a:t>
+            </a:r>
+          </a:p>
+          <a:p>
+            <a:r>
+              <a:t>Applications include customer segmentation for targeted marketing, anomaly detection, document analysis, and image segmentation.</a:t>
             </a:r>
           </a:p>
         </p:txBody>
@@ -5639,7 +5713,7 @@
           <a:lstStyle/>
           <a:p>
             <a:r>
-              <a:t>Unlabeled Data and Pattern Discovery</a:t>
+              <a:t>Dimensionality Reduction: Simplifying Data</a:t>
             </a:r>
           </a:p>
         </p:txBody>
@@ -5660,27 +5734,32 @@
           <a:lstStyle/>
           <a:p>
             <a:r>
-              <a:t>Unlabeled data consists only of input features (x), without corresponding output labels (y).</a:t>
-            </a:r>
-          </a:p>
-          <a:p>
-            <a:r>
-              <a:t>The algorithms must infer structures or properties directly from the distribution of the input features.</a:t>
-            </a:r>
-          </a:p>
-          <a:p>
-            <a:r>
-              <a:t>Pattern discovery involves identifying inherent groupings, dimensions, or relationships that are not explicitly provided.</a:t>
-            </a:r>
-          </a:p>
-          <a:p>
-            <a:r>
-              <a:t>This often leads to insights that might not be immediately obvious through manual inspection of the data.</a:t>
-            </a:r>
-          </a:p>
-          <a:p>
-            <a:r>
-              <a:t>Unsupervised learning can reveal underlying categories or concepts that were previously unknown.</a:t>
+              <a:t>Dimensionality reduction is a technique used to reduce the number of input features (dimensions) in a dataset while retaining as much relevant information as possible.</a:t>
+            </a:r>
+          </a:p>
+          <a:p>
+            <a:r>
+              <a:t>High-dimensional data can suffer from the 'curse of dimensionality,' leading to increased computational cost, sparse data, and potential overfitting.</a:t>
+            </a:r>
+          </a:p>
+          <a:p>
+            <a:r>
+              <a:t>The goals are to improve model performance, reduce storage space, speed up computation, and enable better data visualization in lower dimensions.</a:t>
+            </a:r>
+          </a:p>
+          <a:p>
+            <a:r>
+              <a:t>Feature Selection: Involves choosing a subset of the most relevant existing features from the original set, discarding redundant or irrelevant ones.</a:t>
+            </a:r>
+          </a:p>
+          <a:p>
+            <a:r>
+              <a:t>Feature Extraction: Transforms the data into a lower-dimensional space by creating new, derived features (components) from combinations of the original ones.</a:t>
+            </a:r>
+          </a:p>
+          <a:p>
+            <a:r>
+              <a:t>Common techniques include Principal Component Analysis (PCA) for linear transformations and t-SNE for non-linear visualization of high-dimensional data.</a:t>
             </a:r>
           </a:p>
         </p:txBody>
@@ -5719,7 +5798,7 @@
           <a:lstStyle/>
           <a:p>
             <a:r>
-              <a:t>Common Unsupervised Learning Tasks</a:t>
+              <a:t>Association Rule Learning</a:t>
             </a:r>
           </a:p>
         </p:txBody>
@@ -5740,27 +5819,32 @@
           <a:lstStyle/>
           <a:p>
             <a:r>
-              <a:t>Clustering: Grouping data points into clusters such that points in the same cluster are more similar to each other than to those in other clusters.</a:t>
-            </a:r>
-          </a:p>
-          <a:p>
-            <a:r>
-              <a:t>Dimensionality Reduction: Reducing the number of random variables under consideration by obtaining a set of principal variables.</a:t>
-            </a:r>
-          </a:p>
-          <a:p>
-            <a:r>
-              <a:t>Anomaly Detection: Identifying rare items, events, or observations that deviate significantly from the majority of the data.</a:t>
-            </a:r>
-          </a:p>
-          <a:p>
-            <a:r>
-              <a:t>Association Rule Mining: Discovering interesting relationships or associations among items in large datasets (e.g., market basket analysis).</a:t>
-            </a:r>
-          </a:p>
-          <a:p>
-            <a:r>
-              <a:t>Generative Models: Learning the underlying probability distribution of the data to generate new, similar data instances.</a:t>
+              <a:t>Association rule learning is an unsupervised technique for discovering interesting relationships or associations between variables in large databases.</a:t>
+            </a:r>
+          </a:p>
+          <a:p>
+            <a:r>
+              <a:t>It is widely used for market basket analysis, identifying items that are frequently purchased together (e.g., 'customers who buy bread also buy milk').</a:t>
+            </a:r>
+          </a:p>
+          <a:p>
+            <a:r>
+              <a:t>The relationships are expressed as 'if-then' rules (e.g., {Bread} -&gt; {Milk}), but these rules are not causal; they simply indicate co-occurrence patterns.</a:t>
+            </a:r>
+          </a:p>
+          <a:p>
+            <a:r>
+              <a:t>Key metrics for evaluating association rules are: Support (how frequent the itemset is), Confidence (how often Y appears when X appears), and Lift (how much more likely Y is with X compared to baseline).</a:t>
+            </a:r>
+          </a:p>
+          <a:p>
+            <a:r>
+              <a:t>The Apriori algorithm is a classic method for efficiently finding frequent itemsets and generating association rules by leveraging the anti-monotone property of support.</a:t>
+            </a:r>
+          </a:p>
+          <a:p>
+            <a:r>
+              <a:t>Applications extend beyond retail to medical diagnosis, web usage mining, and bioinformatics for identifying co-occurring patterns.</a:t>
             </a:r>
           </a:p>
         </p:txBody>
@@ -5799,7 +5883,7 @@
           <a:lstStyle/>
           <a:p>
             <a:r>
-              <a:t>Syntax and Semantics of Propositional Logic</a:t>
+              <a:t>Inference Rules in Propositional Logic</a:t>
             </a:r>
           </a:p>
         </p:txBody>
@@ -5820,27 +5904,27 @@
           <a:lstStyle/>
           <a:p>
             <a:r>
-              <a:t>Syntax dictates the well-formed formulas (WFFs) in PL, ensuring grammatically correct logical expressions.</a:t>
-            </a:r>
-          </a:p>
-          <a:p>
-            <a:r>
-              <a:t>A WFF is either an atomic proposition or formed by applying connectives to existing WFFs according to rules.</a:t>
-            </a:r>
-          </a:p>
-          <a:p>
-            <a:r>
-              <a:t>Semantics assigns meaning to WFFs by defining their truth values based on interpretations (truth assignments to atoms).</a:t>
-            </a:r>
-          </a:p>
-          <a:p>
-            <a:r>
-              <a:t>An interpretation is a mapping from propositional symbols to truth values (True/False).</a:t>
-            </a:r>
-          </a:p>
-          <a:p>
-            <a:r>
-              <a:t>A model is an interpretation where all sentences in a knowledge base are true; it represents a possible world.</a:t>
+              <a:t>Inference rules are patterns of reasoning that allow us to deduce new propositions (conclusions) from existing ones (premises) while preserving truth.</a:t>
+            </a:r>
+          </a:p>
+          <a:p>
+            <a:r>
+              <a:t>The most fundamental inference rule is Modus Ponens: From P and P→Q, we can infer Q. This is a sound rule, meaning if premises are true, conclusion is true.</a:t>
+            </a:r>
+          </a:p>
+          <a:p>
+            <a:r>
+              <a:t>Other common rules include Modus Tollens (from ¬Q and P→Q, infer ¬P), Hypothetical Syllogism (from P→Q and Q→R, infer P→R), and Conjunction Introduction.</a:t>
+            </a:r>
+          </a:p>
+          <a:p>
+            <a:r>
+              <a:t>These rules form the basis of deductive reasoning, enabling AI systems to draw valid conclusions from a knowledge base.</a:t>
+            </a:r>
+          </a:p>
+          <a:p>
+            <a:r>
+              <a:t>A proof in propositional logic is a sequence of propositions, where each proposition is either a premise or follows from previous propositions by an inference rule.</a:t>
             </a:r>
           </a:p>
         </p:txBody>
@@ -5879,7 +5963,7 @@
           <a:lstStyle/>
           <a:p>
             <a:r>
-              <a:t>Examples of Unsupervised Algorithms</a:t>
+              <a:t>Applications and Challenges of Unsupervised Learning</a:t>
             </a:r>
           </a:p>
         </p:txBody>
@@ -5900,27 +5984,32 @@
           <a:lstStyle/>
           <a:p>
             <a:r>
-              <a:t>K-Means Clustering: An iterative algorithm that partitions data into K predefined clusters, assigning each data point to the cluster with the nearest mean.</a:t>
-            </a:r>
-          </a:p>
-          <a:p>
-            <a:r>
-              <a:t>Hierarchical Clustering: Builds a hierarchy of clusters, either by starting with individual points and merging them (agglomerative) or starting with one large cluster and splitting it (divisive).</a:t>
-            </a:r>
-          </a:p>
-          <a:p>
-            <a:r>
-              <a:t>Principal Component Analysis (PCA): A linear dimensionality reduction technique that transforms data to a new coordinate system where the greatest variance lies on the first coordinate (principal component).</a:t>
-            </a:r>
-          </a:p>
-          <a:p>
-            <a:r>
-              <a:t>Autoencoders: Neural networks trained to reconstruct their input, learning a compressed representation (encoding) in the process.</a:t>
-            </a:r>
-          </a:p>
-          <a:p>
-            <a:r>
-              <a:t>DBSCAN (Density-Based Spatial Clustering of Applications with Noise): A clustering algorithm that groups together points that are closely packed together, marking as outliers points that lie alone in low-density regions.</a:t>
+              <a:t>Applications: Customer segmentation, anomaly detection (e.g., fraud), data compression, topic modeling in text, recommendation systems, and bioinformatics.</a:t>
+            </a:r>
+          </a:p>
+          <a:p>
+            <a:r>
+              <a:t>Anomaly Detection: Identifying unusual patterns that do not conform to expected behavior, crucial in security and surveillance.</a:t>
+            </a:r>
+          </a:p>
+          <a:p>
+            <a:r>
+              <a:t>Challenges: Lack of ground truth, making objective evaluation of model performance often subjective and difficult.</a:t>
+            </a:r>
+          </a:p>
+          <a:p>
+            <a:r>
+              <a:t>Interpretation: The patterns discovered by algorithms may not always be easily interpretable or directly actionable without domain expertise.</a:t>
+            </a:r>
+          </a:p>
+          <a:p>
+            <a:r>
+              <a:t>Parameter Sensitivity: Many algorithms (e.g., K-Means) require specifying parameters (like 'k') that significantly impact results and may need heuristic methods to choose.</a:t>
+            </a:r>
+          </a:p>
+          <a:p>
+            <a:r>
+              <a:t>Scalability: Processing very large, high-dimensional unlabeled datasets can be computationally intensive.</a:t>
             </a:r>
           </a:p>
         </p:txBody>
@@ -5959,7 +6048,7 @@
           <a:lstStyle/>
           <a:p>
             <a:r>
-              <a:t>Applications and Interpretation in Unsupervised Learning</a:t>
+              <a:t>Classification: Detailed Overview</a:t>
             </a:r>
           </a:p>
         </p:txBody>
@@ -5980,27 +6069,32 @@
           <a:lstStyle/>
           <a:p>
             <a:r>
-              <a:t>Applications: Customer segmentation, anomaly detection (e.g., fraud detection), genetic analysis, document summarization, image compression.</a:t>
-            </a:r>
-          </a:p>
-          <a:p>
-            <a:r>
-              <a:t>In marketing, clustering can identify distinct customer segments for targeted campaigns.</a:t>
-            </a:r>
-          </a:p>
-          <a:p>
-            <a:r>
-              <a:t>Dimensionality reduction helps visualize high-dimensional data and mitigate the curse of dimensionality.</a:t>
-            </a:r>
-          </a:p>
-          <a:p>
-            <a:r>
-              <a:t>Interpretation of results can be more challenging than supervised learning due to the lack of ground truth labels.</a:t>
-            </a:r>
-          </a:p>
-          <a:p>
-            <a:r>
-              <a:t>Often, human domain expertise is required to assign meaning and practical value to the discovered patterns or clusters.</a:t>
+              <a:t>Classification is a supervised machine learning task where the model learns to assign input data points to one of several predefined discrete categories or classes.</a:t>
+            </a:r>
+          </a:p>
+          <a:p>
+            <a:r>
+              <a:t>The goal is to build a model that can predict the class label of new, unseen data based on features learned from labeled training data.</a:t>
+            </a:r>
+          </a:p>
+          <a:p>
+            <a:r>
+              <a:t>Binary Classification: Involves predicting one of two possible outcomes (e.g., 'yes' or 'no,' 'spam' or 'not spam'). This is the simplest and most common form.</a:t>
+            </a:r>
+          </a:p>
+          <a:p>
+            <a:r>
+              <a:t>Multi-class Classification: Involves predicting one of more than two possible outcomes (e.g., classifying images of animals into 'cat,' 'dog,' 'bird,' 'fish').</a:t>
+            </a:r>
+          </a:p>
+          <a:p>
+            <a:r>
+              <a:t>Multi-label Classification: A more complex variant where an instance can be assigned to multiple classes simultaneously (e.g., an image can contain both 'dog' and 'cat').</a:t>
+            </a:r>
+          </a:p>
+          <a:p>
+            <a:r>
+              <a:t>The output of a classifier is typically a probability distribution over the possible classes, from which the most likely class is chosen based on a threshold.</a:t>
             </a:r>
           </a:p>
         </p:txBody>
@@ -6039,7 +6133,7 @@
           <a:lstStyle/>
           <a:p>
             <a:r>
-              <a:t>Classification and Regression: Predicting Outcomes</a:t>
+              <a:t>Common Classification Algorithms</a:t>
             </a:r>
           </a:p>
         </p:txBody>
@@ -6060,27 +6154,32 @@
           <a:lstStyle/>
           <a:p>
             <a:r>
-              <a:t>Classification and Regression are the two primary types of supervised machine learning tasks.</a:t>
-            </a:r>
-          </a:p>
-          <a:p>
-            <a:r>
-              <a:t>Both involve predicting an output variable (target) based on input features, but they differ in the nature of the target.</a:t>
-            </a:r>
-          </a:p>
-          <a:p>
-            <a:r>
-              <a:t>Understanding the distinction is crucial for selecting the appropriate model and evaluation metrics.</a:t>
-            </a:r>
-          </a:p>
-          <a:p>
-            <a:r>
-              <a:t>The choice between classification and regression depends entirely on the type of problem being addressed and the nature of the desired prediction.</a:t>
-            </a:r>
-          </a:p>
-          <a:p>
-            <a:r>
-              <a:t>Many real-world problems can be framed as either a classification or a regression task.</a:t>
+              <a:t>K-Nearest Neighbors (K-NN): A non-parametric, lazy learning algorithm that classifies new data points based on the majority class of their 'k' closest neighbors in the feature space.</a:t>
+            </a:r>
+          </a:p>
+          <a:p>
+            <a:r>
+              <a:t>Support Vector Machines (SVM): Finds an optimal hyperplane in a high-dimensional feature space that best separates data points of different classes, maximizing the margin between them; effective for high-dimensional data.</a:t>
+            </a:r>
+          </a:p>
+          <a:p>
+            <a:r>
+              <a:t>Decision Trees: Hierarchical models that split the data based on features into a tree-like structure, leading to a decision at the leaf nodes; highly interpretable but prone to overfitting without pruning.</a:t>
+            </a:r>
+          </a:p>
+          <a:p>
+            <a:r>
+              <a:t>Logistic Regression: A statistical model used for binary classification. It estimates the probability of a data point belonging to a particular class using a sigmoid function; a linear model.</a:t>
+            </a:r>
+          </a:p>
+          <a:p>
+            <a:r>
+              <a:t>Naive Bayes: A family of probabilistic classifiers based on Bayes' theorem, assuming strong (naive) independence between features; simple, fast, and often effective for text classification.</a:t>
+            </a:r>
+          </a:p>
+          <a:p>
+            <a:r>
+              <a:t>Ensemble Methods (e.g., Random Forest, Gradient Boosting): Combine multiple individual classifiers (often decision trees) to improve overall performance and reduce variance through techniques like bagging or boosting.</a:t>
             </a:r>
           </a:p>
         </p:txBody>
@@ -6119,7 +6218,7 @@
           <a:lstStyle/>
           <a:p>
             <a:r>
-              <a:t>Classification: Predicting Discrete Categories</a:t>
+              <a:t>Regression: Detailed Overview</a:t>
             </a:r>
           </a:p>
         </p:txBody>
@@ -6140,27 +6239,32 @@
           <a:lstStyle/>
           <a:p>
             <a:r>
-              <a:t>Classification is the task of predicting a discrete, categorical label for a given input instance.</a:t>
-            </a:r>
-          </a:p>
-          <a:p>
-            <a:r>
-              <a:t>The output variable is qualitative and belongs to a predefined set of classes or categories.</a:t>
-            </a:r>
-          </a:p>
-          <a:p>
-            <a:r>
-              <a:t>Examples: binary classification (spam/not spam, diseased/healthy) or multi-class classification (dog/cat/bird, sentiment: positive/negative/neutral).</a:t>
-            </a:r>
-          </a:p>
-          <a:p>
-            <a:r>
-              <a:t>The model learns to map input features to one of these discrete classes.</a:t>
-            </a:r>
-          </a:p>
-          <a:p>
-            <a:r>
-              <a:t>Evaluation often focuses on metrics like accuracy, precision, recall, and F1-score, which measure how well the model assigns correct categories.</a:t>
+              <a:t>Regression is a supervised machine learning task focused on predicting a continuous numerical value as output.</a:t>
+            </a:r>
+          </a:p>
+          <a:p>
+            <a:r>
+              <a:t>Unlike classification, the target variable can take any value within a given range, representing quantities or magnitudes, rather than discrete categories.</a:t>
+            </a:r>
+          </a:p>
+          <a:p>
+            <a:r>
+              <a:t>The goal is to model the relationship between one or more independent input features and a dependent continuous output variable.</a:t>
+            </a:r>
+          </a:p>
+          <a:p>
+            <a:r>
+              <a:t>The output of a regression model is typically a single numerical value (e.g., a predicted price, temperature, or age).</a:t>
+            </a:r>
+          </a:p>
+          <a:p>
+            <a:r>
+              <a:t>Regression models are widely used for forecasting, prediction, and understanding the impact of features on an outcome, such as demand prediction or risk assessment.</a:t>
+            </a:r>
+          </a:p>
+          <a:p>
+            <a:r>
+              <a:t>The 'fit' of a regression model is often visualized by plotting the predicted values against the actual values, ideally showing a close alignment along a 45-degree line.</a:t>
             </a:r>
           </a:p>
         </p:txBody>
@@ -6199,7 +6303,7 @@
           <a:lstStyle/>
           <a:p>
             <a:r>
-              <a:t>Key Classification Algorithms</a:t>
+              <a:t>Common Regression Algorithms</a:t>
             </a:r>
           </a:p>
         </p:txBody>
@@ -6220,27 +6324,32 @@
           <a:lstStyle/>
           <a:p>
             <a:r>
-              <a:t>Logistic Regression: A linear model for binary classification, estimating the probability of a given input belonging to a particular class.</a:t>
-            </a:r>
-          </a:p>
-          <a:p>
-            <a:r>
-              <a:t>Support Vector Machines (SVM): Finds an optimal hyperplane that best separates data points into different classes, maximizing the margin between them.</a:t>
-            </a:r>
-          </a:p>
-          <a:p>
-            <a:r>
-              <a:t>K-Nearest Neighbors (KNN): Classifies a new data point by finding the 'k' closest points in the training data and assigning the majority class.</a:t>
-            </a:r>
-          </a:p>
-          <a:p>
-            <a:r>
-              <a:t>Decision Trees &amp; Random Forests: Tree-based models that make decisions by recursively splitting data based on features, with Random Forests combining multiple trees to improve robustness.</a:t>
-            </a:r>
-          </a:p>
-          <a:p>
-            <a:r>
-              <a:t>Naive Bayes: A probabilistic classifier based on Bayes' theorem with strong independence assumptions between features, often effective for text classification.</a:t>
+              <a:t>Linear Regression: The most basic form, models the relationship between the dependent variable and independent variables as a straight line (or hyperplane in higher dimensions), assuming a linear relationship.</a:t>
+            </a:r>
+          </a:p>
+          <a:p>
+            <a:r>
+              <a:t>Polynomial Regression: Extends linear regression by modeling the relationship as an nth-degree polynomial, allowing for capturing non-linear relationships between variables.</a:t>
+            </a:r>
+          </a:p>
+          <a:p>
+            <a:r>
+              <a:t>Ridge and Lasso Regression: Regularized versions of linear regression that add a penalty term to the loss function to prevent overfitting and handle multicollinearity, with Lasso also performing feature selection by shrinking coefficients to zero.</a:t>
+            </a:r>
+          </a:p>
+          <a:p>
+            <a:r>
+              <a:t>Decision Tree Regressor: Similar to classification trees, but the leaf nodes predict a continuous value (often the mean of the target values of the training instances in that leaf).</a:t>
+            </a:r>
+          </a:p>
+          <a:p>
+            <a:r>
+              <a:t>Support Vector Regression (SVR): An adaptation of SVMs for regression tasks. It finds a function that deviates from the actual target values by no more than a certain epsilon (ε), while being as flat as possible.</a:t>
+            </a:r>
+          </a:p>
+          <a:p>
+            <a:r>
+              <a:t>Ensemble Methods (e.g., Random Forest Regressor, Gradient Boosting Regressor): Combine multiple decision trees to produce more robust and accurate predictions by averaging their outputs, reducing bias and variance.</a:t>
             </a:r>
           </a:p>
         </p:txBody>
@@ -6279,7 +6388,7 @@
           <a:lstStyle/>
           <a:p>
             <a:r>
-              <a:t>Regression: Predicting Continuous Values</a:t>
+              <a:t>Model Selection and Hyperparameter Tuning</a:t>
             </a:r>
           </a:p>
         </p:txBody>
@@ -6300,27 +6409,32 @@
           <a:lstStyle/>
           <a:p>
             <a:r>
-              <a:t>Regression is the task of predicting a continuous numerical value for a given input instance.</a:t>
-            </a:r>
-          </a:p>
-          <a:p>
-            <a:r>
-              <a:t>The output variable is quantitative and can take any value within a range.</a:t>
-            </a:r>
-          </a:p>
-          <a:p>
-            <a:r>
-              <a:t>Examples: predicting house prices, stock market fluctuations, temperature, or a person's age.</a:t>
-            </a:r>
-          </a:p>
-          <a:p>
-            <a:r>
-              <a:t>The model learns a function that estimates the relationship between input features and the continuous target.</a:t>
-            </a:r>
-          </a:p>
-          <a:p>
-            <a:r>
-              <a:t>Evaluation focuses on metrics like Mean Squared Error (MSE), Root Mean Squared Error (RMSE), and R-squared, which measure the proximity of predictions to actual values.</a:t>
+              <a:t>Model Selection: The process of choosing the most appropriate machine learning algorithm and architecture for a given task and dataset.</a:t>
+            </a:r>
+          </a:p>
+          <a:p>
+            <a:r>
+              <a:t>Involves considering factors like data type, dataset size, problem complexity, interpretability requirements, and computational resources, often through comparative evaluation.</a:t>
+            </a:r>
+          </a:p>
+          <a:p>
+            <a:r>
+              <a:t>Hyperparameters: Configuration settings external to the model that are not learned from the data during training but are set prior (e.g., 'k' in K-NN, 'C' in SVM, 'max_depth' in Decision Trees).</a:t>
+            </a:r>
+          </a:p>
+          <a:p>
+            <a:r>
+              <a:t>Hyperparameter Tuning: The process of finding the optimal set of hyperparameters that yields the best model performance on unseen data (typically a validation set).</a:t>
+            </a:r>
+          </a:p>
+          <a:p>
+            <a:r>
+              <a:t>Techniques include Grid Search (exhaustively searches a predefined space), Random Search (randomly samples combinations), and Bayesian Optimization (intelligently explores promising regions).</a:t>
+            </a:r>
+          </a:p>
+          <a:p>
+            <a:r>
+              <a:t>Effective model selection and hyperparameter tuning are crucial for maximizing the generalization capability and real-world performance of a machine learning model.</a:t>
             </a:r>
           </a:p>
         </p:txBody>
@@ -6359,7 +6473,7 @@
           <a:lstStyle/>
           <a:p>
             <a:r>
-              <a:t>Key Regression Algorithms</a:t>
+              <a:t>Importance of Model Evaluation</a:t>
             </a:r>
           </a:p>
         </p:txBody>
@@ -6380,27 +6494,27 @@
           <a:lstStyle/>
           <a:p>
             <a:r>
-              <a:t>Linear Regression: Models a linear relationship between input features and the continuous target variable (y = mx + b).</a:t>
-            </a:r>
-          </a:p>
-          <a:p>
-            <a:r>
-              <a:t>Polynomial Regression: Extends linear regression by modeling a non-linear relationship using polynomial functions of the features.</a:t>
-            </a:r>
-          </a:p>
-          <a:p>
-            <a:r>
-              <a:t>Decision Tree Regressor: A tree-based model that predicts a continuous value by partitioning the feature space into regions and taking the average target value within each region.</a:t>
-            </a:r>
-          </a:p>
-          <a:p>
-            <a:r>
-              <a:t>Random Forest Regressor: An ensemble method that combines multiple decision tree regressors to improve prediction accuracy and reduce overfitting.</a:t>
-            </a:r>
-          </a:p>
-          <a:p>
-            <a:r>
-              <a:t>Support Vector Regression (SVR): An extension of SVMs that uses a similar principle to find a function that best fits the data within a specified margin of error.</a:t>
+              <a:t>Model evaluation is a critical step in the machine learning workflow, assessing how well a trained model performs on unseen data.</a:t>
+            </a:r>
+          </a:p>
+          <a:p>
+            <a:r>
+              <a:t>It provides objective measures to compare different models, tune hyperparameters, and understand a model's strengths and weaknesses beyond just training performance.</a:t>
+            </a:r>
+          </a:p>
+          <a:p>
+            <a:r>
+              <a:t>Without proper evaluation, it's impossible to determine if a model has truly learned generalizable patterns or merely memorized the training data (overfitting).</a:t>
+            </a:r>
+          </a:p>
+          <a:p>
+            <a:r>
+              <a:t>Evaluation metrics help quantify a model's prediction accuracy, reliability, and utility in real-world scenarios, ensuring it meets problem requirements.</a:t>
+            </a:r>
+          </a:p>
+          <a:p>
+            <a:r>
+              <a:t>Choosing the right evaluation metric is crucial as different metrics highlight different aspects of model performance and can lead to different conclusions, especially with imbalanced datasets or specific business objectives.</a:t>
             </a:r>
           </a:p>
         </p:txBody>
@@ -6439,7 +6553,7 @@
           <a:lstStyle/>
           <a:p>
             <a:r>
-              <a:t>Evaluation Metrics: Assessing Model Performance</a:t>
+              <a:t>Metrics for Classification (Part 1)</a:t>
             </a:r>
           </a:p>
         </p:txBody>
@@ -6460,27 +6574,32 @@
           <a:lstStyle/>
           <a:p>
             <a:r>
-              <a:t>Evaluation metrics are quantitative measures used to assess how well a machine learning model performs.</a:t>
-            </a:r>
-          </a:p>
-          <a:p>
-            <a:r>
-              <a:t>Choosing appropriate metrics is crucial for understanding a model's strengths, weaknesses, and suitability for a task.</a:t>
-            </a:r>
-          </a:p>
-          <a:p>
-            <a:r>
-              <a:t>Different tasks (classification vs. regression) require different sets of metrics to meaningfully quantify performance.</a:t>
-            </a:r>
-          </a:p>
-          <a:p>
-            <a:r>
-              <a:t>Metrics help in comparing different models, fine-tuning hyperparameters, and ensuring generalization to unseen data.</a:t>
-            </a:r>
-          </a:p>
-          <a:p>
-            <a:r>
-              <a:t>It's important to select metrics that align with the specific goals and real-world implications of the AI application.</a:t>
+              <a:t>Accuracy: The proportion of correctly classified instances out of the total instances. Formula: (TP + TN) / (TP + TN + FP + FN).</a:t>
+            </a:r>
+          </a:p>
+          <a:p>
+            <a:r>
+              <a:t>Accuracy can be misleading for imbalanced datasets, where a high accuracy might be achieved by simply predicting the majority class.</a:t>
+            </a:r>
+          </a:p>
+          <a:p>
+            <a:r>
+              <a:t>Precision (Positive Predictive Value): Measures the proportion of correctly predicted positive observations among all observations predicted as positive. Formula: TP / (TP + FP). Important when the cost of false positives is high.</a:t>
+            </a:r>
+          </a:p>
+          <a:p>
+            <a:r>
+              <a:t>Recall (Sensitivity or True Positive Rate): Measures the proportion of correctly predicted positive observations among all actual positives. Formula: TP / (TP + FN). Important when the cost of false negatives is high.</a:t>
+            </a:r>
+          </a:p>
+          <a:p>
+            <a:r>
+              <a:t>F1-Score: The harmonic mean of Precision and Recall, providing a balanced measure. Formula: 2 * (Precision * Recall) / (Precision + Recall). Useful when there is an uneven class distribution.</a:t>
+            </a:r>
+          </a:p>
+          <a:p>
+            <a:r>
+              <a:t>TP: True Positives, TN: True Negatives, FP: False Positives, FN: False Negatives.</a:t>
             </a:r>
           </a:p>
         </p:txBody>
@@ -6519,7 +6638,7 @@
           <a:lstStyle/>
           <a:p>
             <a:r>
-              <a:t>Metrics for Classification: Accuracy, Precision, Recall, F1-Score</a:t>
+              <a:t>Confusion Matrix and ROC Curves</a:t>
             </a:r>
           </a:p>
         </p:txBody>
@@ -6540,27 +6659,32 @@
           <a:lstStyle/>
           <a:p>
             <a:r>
-              <a:t>Accuracy: The proportion of correctly classified instances out of the total instances. (TP+TN)/(TP+TN+FP+FN)</a:t>
-            </a:r>
-          </a:p>
-          <a:p>
-            <a:r>
-              <a:t>Precision: The proportion of true positive predictions among all positive predictions. (TP)/(TP+FP) - measures relevance of positive predictions.</a:t>
-            </a:r>
-          </a:p>
-          <a:p>
-            <a:r>
-              <a:t>Recall (Sensitivity): The proportion of true positive predictions among all actual positive instances. (TP)/(TP+FN) - measures how many actual positives were caught.</a:t>
-            </a:r>
-          </a:p>
-          <a:p>
-            <a:r>
-              <a:t>F1-Score: The harmonic mean of Precision and Recall, providing a single metric that balances both. 2 * (Precision * Recall) / (Precision + Recall).</a:t>
-            </a:r>
-          </a:p>
-          <a:p>
-            <a:r>
-              <a:t>These metrics are particularly important when dealing with imbalanced datasets where accuracy alone can be misleading.</a:t>
+              <a:t>Confusion Matrix: A table used to describe the performance of a classification model, breaking down predictions into True Positives (TP), True Negatives (TN), False Positives (FP), and False Negatives (FN).</a:t>
+            </a:r>
+          </a:p>
+          <a:p>
+            <a:r>
+              <a:t>Provides detailed insight into where the model is making errors (Type I: FP, Type II: FN), beyond just a single accuracy number, and is essential for calculating precision, recall, and specificity.</a:t>
+            </a:r>
+          </a:p>
+          <a:p>
+            <a:r>
+              <a:t>ROC (Receiver Operating Characteristic) Curve: A plot illustrating the diagnostic ability of a binary classifier system as its discrimination threshold is varied.</a:t>
+            </a:r>
+          </a:p>
+          <a:p>
+            <a:r>
+              <a:t>It plots the True Positive Rate (Recall) against the False Positive Rate (1 - Specificity) at various threshold settings, with a curve closer to the top-left indicating better performance.</a:t>
+            </a:r>
+          </a:p>
+          <a:p>
+            <a:r>
+              <a:t>AUC (Area Under the Curve): The area under the ROC curve, representing the probability that the classifier will rank a randomly chosen positive instance higher than a randomly chosen negative instance.</a:t>
+            </a:r>
+          </a:p>
+          <a:p>
+            <a:r>
+              <a:t>AUC values range from 0.5 (random) to 1.0 (perfect), useful for comparing different models regardless of their specific operating thresholds and for imbalanced datasets.</a:t>
             </a:r>
           </a:p>
         </p:txBody>
@@ -6599,7 +6723,7 @@
           <a:lstStyle/>
           <a:p>
             <a:r>
-              <a:t>Understanding the Confusion Matrix</a:t>
+              <a:t>Metrics for Regression</a:t>
             </a:r>
           </a:p>
         </p:txBody>
@@ -6620,32 +6744,32 @@
           <a:lstStyle/>
           <a:p>
             <a:r>
-              <a:t>A Confusion Matrix is a table used to summarize the performance of a classification algorithm.</a:t>
-            </a:r>
-          </a:p>
-          <a:p>
-            <a:r>
-              <a:t>It displays the number of True Positives (TP), True Negatives (TN), False Positives (FP), and False Negatives (FN).</a:t>
-            </a:r>
-          </a:p>
-          <a:p>
-            <a:r>
-              <a:t>True Positives (TP): Correctly predicted positive instances (e.g., predicted spam, actually spam).</a:t>
-            </a:r>
-          </a:p>
-          <a:p>
-            <a:r>
-              <a:t>True Negatives (TN): Correctly predicted negative instances (e.g., predicted not spam, actually not spam).</a:t>
-            </a:r>
-          </a:p>
-          <a:p>
-            <a:r>
-              <a:t>False Positives (FP) / Type I Error: Incorrectly predicted positive instances (e.g., predicted spam, actually not spam).</a:t>
-            </a:r>
-          </a:p>
-          <a:p>
-            <a:r>
-              <a:t>False Negatives (FN) / Type II Error: Incorrectly predicted negative instances (e.g., predicted not spam, actually spam).</a:t>
+              <a:t>Regression metrics quantify the difference between the predicted continuous values and the actual observed values, typically measuring error or fit.</a:t>
+            </a:r>
+          </a:p>
+          <a:p>
+            <a:r>
+              <a:t>Mean Absolute Error (MAE): The average of the absolute differences between predictions and actual values. Formula: (1/N) * Σ |Yi_actual - Yi_predicted|. It's robust to outliers.</a:t>
+            </a:r>
+          </a:p>
+          <a:p>
+            <a:r>
+              <a:t>Mean Squared Error (MSE): The average of the squared differences between predictions and actual values. Formula: (1/N) * Σ (Yi_actual - Yi_predicted)^2. It penalizes larger errors more heavily.</a:t>
+            </a:r>
+          </a:p>
+          <a:p>
+            <a:r>
+              <a:t>Root Mean Squared Error (RMSE): The square root of the MSE. It's often preferred over MSE because it's in the same units as the target variable, making it more interpretable. Formula: √MSE.</a:t>
+            </a:r>
+          </a:p>
+          <a:p>
+            <a:r>
+              <a:t>R-squared (Coefficient of Determination): Represents the proportion of the variance in the dependent variable that is predictable from the independent variables. Formula: 1 - (SS_res / SS_tot).</a:t>
+            </a:r>
+          </a:p>
+          <a:p>
+            <a:r>
+              <a:t>R-squared ranges from 0 to 1 (or sometimes negative); a higher value indicates a better fit. The choice of regression metric depends on the problem's sensitivity to large errors and the need for interpretability.</a:t>
             </a:r>
           </a:p>
         </p:txBody>
@@ -6684,7 +6808,7 @@
           <a:lstStyle/>
           <a:p>
             <a:r>
-              <a:t>Inference in Propositional Logic</a:t>
+              <a:t>Limitations of Propositional Logic</a:t>
             </a:r>
           </a:p>
         </p:txBody>
@@ -6705,27 +6829,27 @@
           <a:lstStyle/>
           <a:p>
             <a:r>
-              <a:t>Inference in PL involves deriving new logical sentences from a set of initial sentences (knowledge base) using inference rules.</a:t>
-            </a:r>
-          </a:p>
-          <a:p>
-            <a:r>
-              <a:t>Modus Ponens is a fundamental rule: From (P → Q) and P, infer Q.</a:t>
-            </a:r>
-          </a:p>
-          <a:p>
-            <a:r>
-              <a:t>Resolution is a powerful inference rule, particularly useful for automated theorem proving by refutation.</a:t>
-            </a:r>
-          </a:p>
-          <a:p>
-            <a:r>
-              <a:t>Forward chaining starts with known facts and applies rules to infer new facts until the goal is reached.</a:t>
-            </a:r>
-          </a:p>
-          <a:p>
-            <a:r>
-              <a:t>Backward chaining starts from the goal and works backward to find facts that support it, proving its truth.</a:t>
+              <a:t>Propositional logic lacks the ability to represent the internal structure of propositions or relationships between objects.</a:t>
+            </a:r>
+          </a:p>
+          <a:p>
+            <a:r>
+              <a:t>It cannot express quantified statements like 'All humans are mortal' or 'There exists a number greater than 10.'</a:t>
+            </a:r>
+          </a:p>
+          <a:p>
+            <a:r>
+              <a:t>To represent 'All students passed the exam,' one would need a separate propositional variable for each student, leading to an explosion of propositions for larger domains.</a:t>
+            </a:r>
+          </a:p>
+          <a:p>
+            <a:r>
+              <a:t>This limitation makes it unsuitable for complex domains where objects, their properties, and relationships need to be explicitly modeled.</a:t>
+            </a:r>
+          </a:p>
+          <a:p>
+            <a:r>
+              <a:t>Predicate logic extends propositional logic to overcome these limitations by introducing predicates, terms, and quantifiers, allowing for a richer knowledge representation.</a:t>
             </a:r>
           </a:p>
         </p:txBody>
@@ -6764,7 +6888,7 @@
           <a:lstStyle/>
           <a:p>
             <a:r>
-              <a:t>Metrics for Regression: MSE, RMSE, MAE, R-squared</a:t>
+              <a:t>Cross-Validation and Overfitting/Underfitting</a:t>
             </a:r>
           </a:p>
         </p:txBody>
@@ -6785,107 +6909,32 @@
           <a:lstStyle/>
           <a:p>
             <a:r>
-              <a:t>Mean Squared Error (MSE): The average of the squared differences between predicted and actual values. Penalizes larger errors more.</a:t>
-            </a:r>
-          </a:p>
-          <a:p>
-            <a:r>
-              <a:t>Root Mean Squared Error (RMSE): The square root of the MSE, bringing the error back to the original units of the target variable. Easier to interpret.</a:t>
-            </a:r>
-          </a:p>
-          <a:p>
-            <a:r>
-              <a:t>Mean Absolute Error (MAE): The average of the absolute differences between predicted and actual values. Less sensitive to outliers than MSE/RMSE.</a:t>
-            </a:r>
-          </a:p>
-          <a:p>
-            <a:r>
-              <a:t>R-squared (Coefficient of Determination): Represents the proportion of variance in the dependent variable that is predictable from the independent variables.</a:t>
-            </a:r>
-          </a:p>
-          <a:p>
-            <a:r>
-              <a:t>R-squared values range from 0 to 1, where higher values indicate a better fit (1 means the model explains all variability).</a:t>
-            </a:r>
-          </a:p>
-        </p:txBody>
-      </p:sp>
-    </p:spTree>
-  </p:cSld>
-  <p:clrMapOvr>
-    <a:masterClrMapping/>
-  </p:clrMapOvr>
-</p:sld>
-</file>
-
-<file path=ppt/slides/slide51.xml><?xml version="1.0" encoding="utf-8"?>
-<p:sld xmlns:a="http://schemas.openxmlformats.org/drawingml/2006/main" xmlns:p="http://schemas.openxmlformats.org/presentationml/2006/main" xmlns:r="http://schemas.openxmlformats.org/officeDocument/2006/relationships">
-  <p:cSld>
-    <p:spTree>
-      <p:nvGrpSpPr>
-        <p:cNvPr id="1" name=""/>
-        <p:cNvGrpSpPr/>
-        <p:nvPr/>
-      </p:nvGrpSpPr>
-      <p:grpSpPr/>
-      <p:sp>
-        <p:nvSpPr>
-          <p:cNvPr id="2" name="Title 1"/>
-          <p:cNvSpPr>
-            <a:spLocks noGrp="1"/>
-          </p:cNvSpPr>
-          <p:nvPr>
-            <p:ph type="title"/>
-          </p:nvPr>
-        </p:nvSpPr>
-        <p:spPr/>
-        <p:txBody>
-          <a:bodyPr/>
-          <a:lstStyle/>
-          <a:p>
-            <a:r>
-              <a:t>Overfitting, Underfitting, and Cross-Validation</a:t>
-            </a:r>
-          </a:p>
-        </p:txBody>
-      </p:sp>
-      <p:sp>
-        <p:nvSpPr>
-          <p:cNvPr id="3" name="Content Placeholder 2"/>
-          <p:cNvSpPr>
-            <a:spLocks noGrp="1"/>
-          </p:cNvSpPr>
-          <p:nvPr>
-            <p:ph idx="1"/>
-          </p:nvPr>
-        </p:nvSpPr>
-        <p:spPr/>
-        <p:txBody>
-          <a:bodyPr/>
-          <a:lstStyle/>
-          <a:p>
-            <a:r>
-              <a:t>Overfitting: Occurs when a model learns the training data too well, including noise, leading to poor generalization on new data.</a:t>
-            </a:r>
-          </a:p>
-          <a:p>
-            <a:r>
-              <a:t>Underfitting: Occurs when a model is too simple to capture the underlying patterns in the data, performing poorly on both training and test data.</a:t>
-            </a:r>
-          </a:p>
-          <a:p>
-            <a:r>
-              <a:t>Cross-Validation: A resampling procedure used to evaluate ML models on a limited data sample, improving robustness of evaluation.</a:t>
-            </a:r>
-          </a:p>
-          <a:p>
-            <a:r>
-              <a:t>K-Fold Cross-Validation: Divides the dataset into K folds; the model is trained on K-1 folds and validated on the remaining fold, repeating K times.</a:t>
-            </a:r>
-          </a:p>
-          <a:p>
-            <a:r>
-              <a:t>This helps in getting a more reliable estimate of a model's performance on unseen data and in detecting overfitting.</a:t>
+              <a:t>Overfitting: Occurs when a model learns the training data too well, including its noise, leading to poor performance on new, unseen data; the model is too complex.</a:t>
+            </a:r>
+          </a:p>
+          <a:p>
+            <a:r>
+              <a:t>Indicated by high performance on training data but significantly lower performance on test/validation data.</a:t>
+            </a:r>
+          </a:p>
+          <a:p>
+            <a:r>
+              <a:t>Underfitting: Occurs when a model is too simple to capture the underlying patterns in the training data, resulting in poor performance on both training and test data.</a:t>
+            </a:r>
+          </a:p>
+          <a:p>
+            <a:r>
+              <a:t>Cross-Validation: A technique to assess how the results of a statistical analysis will generalize to an independent dataset, mitigating overfitting and selection bias.</a:t>
+            </a:r>
+          </a:p>
+          <a:p>
+            <a:r>
+              <a:t>K-Fold Cross-Validation: The most common method; data is split into 'k' folds, model trained 'k' times (using 'k-1' folds for training, one for validation), and results averaged.</a:t>
+            </a:r>
+          </a:p>
+          <a:p>
+            <a:r>
+              <a:t>This provides a more robust estimate of a model's generalization performance than a single train-test split, crucial for reliable model evaluation and hyperparameter tuning.</a:t>
             </a:r>
           </a:p>
         </p:txBody>
@@ -6924,7 +6973,7 @@
           <a:lstStyle/>
           <a:p>
             <a:r>
-              <a:t>Limitations of Propositional Logic</a:t>
+              <a:t>Introduction to Predicate Logic</a:t>
             </a:r>
           </a:p>
         </p:txBody>
@@ -6945,27 +6994,27 @@
           <a:lstStyle/>
           <a:p>
             <a:r>
-              <a:t>PL lacks the ability to represent relationships between objects or express general statements about groups of objects.</a:t>
-            </a:r>
-          </a:p>
-          <a:p>
-            <a:r>
-              <a:t>It cannot quantify over variables, making it difficult to express statements like 'All birds can fly'.</a:t>
-            </a:r>
-          </a:p>
-          <a:p>
-            <a:r>
-              <a:t>Each specific instance or fact requires its own unique propositional symbol, leading to a proliferation of symbols.</a:t>
-            </a:r>
-          </a:p>
-          <a:p>
-            <a:r>
-              <a:t>For example, to state 'Socrates is a human' and 'Plato is a human' requires two distinct propositions.</a:t>
-            </a:r>
-          </a:p>
-          <a:p>
-            <a:r>
-              <a:t>These limitations restrict its applicability to complex real-world problems requiring fine-grained detail and generalization.</a:t>
+              <a:t>Predicate logic, also known as First-Order Logic (FOL) or First-Order Predicate Calculus, is a powerful extension of propositional logic.</a:t>
+            </a:r>
+          </a:p>
+          <a:p>
+            <a:r>
+              <a:t>It allows for the representation of complex knowledge involving objects, properties of objects, and relationships between objects.</a:t>
+            </a:r>
+          </a:p>
+          <a:p>
+            <a:r>
+              <a:t>Unlike propositional logic which treats propositions as atomic, FOL decomposes propositions into predicates, terms (constants, variables, functions), and quantifiers.</a:t>
+            </a:r>
+          </a:p>
+          <a:p>
+            <a:r>
+              <a:t>This expressive power makes FOL a cornerstone for knowledge representation in AI, enabling more granular and detailed reasoning.</a:t>
+            </a:r>
+          </a:p>
+          <a:p>
+            <a:r>
+              <a:t>It provides a formal language for expressing statements like 'Socrates is a man' (Man(Socrates)) or 'All men are mortal' (∀x (Man(x) → Mortal(x))).</a:t>
             </a:r>
           </a:p>
         </p:txBody>
@@ -7004,7 +7053,7 @@
           <a:lstStyle/>
           <a:p>
             <a:r>
-              <a:t>Predicate Logic (First-Order Logic): Expanding Expressiveness</a:t>
+              <a:t>Quantifiers: Universal and Existential</a:t>
             </a:r>
           </a:p>
         </p:txBody>
@@ -7025,27 +7074,27 @@
           <a:lstStyle/>
           <a:p>
             <a:r>
-              <a:t>Predicate Logic, also known as First-Order Logic (FOL), overcomes the limitations of Propositional Logic.</a:t>
-            </a:r>
-          </a:p>
-          <a:p>
-            <a:r>
-              <a:t>It allows for the representation of objects, properties of objects, and relationships between objects.</a:t>
-            </a:r>
-          </a:p>
-          <a:p>
-            <a:r>
-              <a:t>FOL is a more expressive language for knowledge representation, capable of capturing more nuanced meanings.</a:t>
-            </a:r>
-          </a:p>
-          <a:p>
-            <a:r>
-              <a:t>It forms the basis for many advanced AI systems, particularly in areas like logical reasoning and knowledge graphs.</a:t>
-            </a:r>
-          </a:p>
-          <a:p>
-            <a:r>
-              <a:t>FOL introduces predicates, functions, and quantifiers, enabling rich and detailed declarative knowledge.</a:t>
+              <a:t>Quantifiers are symbols that specify the range or scope of variables in a logical expression.</a:t>
+            </a:r>
+          </a:p>
+          <a:p>
+            <a:r>
+              <a:t>The Universal Quantifier (∀, 'for all' or 'for every') asserts that a statement holds true for every object in the domain of discourse. Example: ∀x P(x) means P(x) is true for all x.</a:t>
+            </a:r>
+          </a:p>
+          <a:p>
+            <a:r>
+              <a:t>The Existential Quantifier (∃, 'there exists' or 'for some') asserts that a statement holds true for at least one object in the domain. Example: ∃x P(x) means there is at least one x for which P(x) is true.</a:t>
+            </a:r>
+          </a:p>
+          <a:p>
+            <a:r>
+              <a:t>Quantifiers allow us to make general statements about collections of objects without enumerating each instance individually.</a:t>
+            </a:r>
+          </a:p>
+          <a:p>
+            <a:r>
+              <a:t>Their proper use is essential for representing general knowledge, rules, and constraints within a domain.</a:t>
             </a:r>
           </a:p>
         </p:txBody>
@@ -7084,7 +7133,7 @@
           <a:lstStyle/>
           <a:p>
             <a:r>
-              <a:t>Syntax of Predicate Logic</a:t>
+              <a:t>Terms, Predicates, and Atomic Sentences</a:t>
             </a:r>
           </a:p>
         </p:txBody>
@@ -7105,27 +7154,27 @@
           <a:lstStyle/>
           <a:p>
             <a:r>
-              <a:t>FOL syntax includes constants (specific objects: 'John', '2'), variables (x, y, z for any object).</a:t>
-            </a:r>
-          </a:p>
-          <a:p>
-            <a:r>
-              <a:t>Predicates represent properties of objects (e.g., 'IsHuman(John)') or relations between objects (e.g., 'Likes(John, Mary)').</a:t>
-            </a:r>
-          </a:p>
-          <a:p>
-            <a:r>
-              <a:t>Functions map tuples of objects to single objects (e.g., 'FatherOf(John)' returns John's father).</a:t>
-            </a:r>
-          </a:p>
-          <a:p>
-            <a:r>
-              <a:t>Atomic sentences are formed by a predicate symbol followed by a list of terms (constants, variables, functions).</a:t>
-            </a:r>
-          </a:p>
-          <a:p>
-            <a:r>
-              <a:t>Complex sentences are built using logical connectives (¬, ∧, ∨, →, ↔) and quantifiers (∀, ∃) on atomic sentences.</a:t>
+              <a:t>Terms in FOL refer to objects in the domain. They can be: Constants (e.g., 'Socrates'), Variables (e.g., x, y), or Functions (e.g., MotherOf(John)).</a:t>
+            </a:r>
+          </a:p>
+          <a:p>
+            <a:r>
+              <a:t>Predicates represent properties of objects or relationships between objects. They take one or more terms as arguments and evaluate to true or false. Examples: Man(Socrates), Loves(John, Mary).</a:t>
+            </a:r>
+          </a:p>
+          <a:p>
+            <a:r>
+              <a:t>An atomic sentence is formed by a predicate symbol followed by a list of terms enclosed in parentheses. These are the basic building blocks of complex FOL sentences.</a:t>
+            </a:r>
+          </a:p>
+          <a:p>
+            <a:r>
+              <a:t>Complex sentences are formed by combining atomic sentences using logical connectives (¬, ∧, ∨, →, ↔) and quantifiers, similar to propositional logic.</a:t>
+            </a:r>
+          </a:p>
+          <a:p>
+            <a:r>
+              <a:t>The ability to decompose statements into these components provides a rich framework for structured knowledge representation.</a:t>
             </a:r>
           </a:p>
         </p:txBody>
@@ -7164,7 +7213,7 @@
           <a:lstStyle/>
           <a:p>
             <a:r>
-              <a:t>Semantics of Predicate Logic</a:t>
+              <a:t>Inference Rules in Predicate Logic</a:t>
             </a:r>
           </a:p>
         </p:txBody>
@@ -7185,27 +7234,27 @@
           <a:lstStyle/>
           <a:p>
             <a:r>
-              <a:t>Semantics in FOL assigns meaning to terms and formulas within an interpretation or model.</a:t>
-            </a:r>
-          </a:p>
-          <a:p>
-            <a:r>
-              <a:t>An interpretation specifies a domain of discourse (a set of objects) and maps constants to objects, predicates to relations, and functions to functions over this domain.</a:t>
-            </a:r>
-          </a:p>
-          <a:p>
-            <a:r>
-              <a:t>A ground term refers to an object in the domain, while a variable can refer to any object.</a:t>
-            </a:r>
-          </a:p>
-          <a:p>
-            <a:r>
-              <a:t>The truth value of an atomic sentence is determined by whether the objects referred to by its terms satisfy the relation defined by the predicate.</a:t>
-            </a:r>
-          </a:p>
-          <a:p>
-            <a:r>
-              <a:t>The truth of complex sentences is evaluated based on the truth values of their components and the definitions of connectives and quantifiers.</a:t>
+              <a:t>Inference rules from propositional logic (Modus Ponens, Modus Tollens, etc.) still apply to predicate logic, operating on fully instantiated sentences.</a:t>
+            </a:r>
+          </a:p>
+          <a:p>
+            <a:r>
+              <a:t>New inference rules are introduced specifically for handling quantifiers, such as Universal Instantiation (UI) and Existential Generalization (EG).</a:t>
+            </a:r>
+          </a:p>
+          <a:p>
+            <a:r>
+              <a:t>Universal Instantiation (UI): From ∀x P(x), infer P(c) for any constant c in the domain.</a:t>
+            </a:r>
+          </a:p>
+          <a:p>
+            <a:r>
+              <a:t>Existential Instantiation (EI): From ∃x P(x), infer P(k) for some new constant k (Skolem constant) that has not been used before.</a:t>
+            </a:r>
+          </a:p>
+          <a:p>
+            <a:r>
+              <a:t>These rules enable AI systems to reason about general statements and specific instances within a knowledge base, allowing for complex deductions.</a:t>
             </a:r>
           </a:p>
         </p:txBody>

</xml_diff>